<commit_message>
Route intro deck agent flow through Testbot and Fixbot
Slide 3 now shows the backend Cortex agents as connected nodes: Testbot
launches category agents and receives SUMMARIZER results, while Fixbot
uses REMEDIATOR previews for human approval. Other slides are unchanged.

Generated with [Snowflake CoCo](https://docs.snowflake.com/en/user-guide/cortex-code/cortex-code)

Co-authored-by: Snowflake CoCo <noreply@snowflake.com>
</commit_message>
<xml_diff>
--- a/build/ShieldBot_Intro.pptx
+++ b/build/ShieldBot_Intro.pptx
@@ -7117,83 +7117,13 @@
       </p:sp>
       <p:sp>
         <p:nvSpPr>
-          <p:cNvPr id="33" name="TextBox 32"/>
-          <p:cNvSpPr txBox="1"/>
-          <p:nvPr/>
-        </p:nvSpPr>
-        <p:spPr>
-          <a:xfrm>
-            <a:off x="777240" y="3172968"/>
-            <a:ext cx="2834640" cy="274320"/>
-          </a:xfrm>
-          <a:prstGeom prst="rect">
-            <a:avLst/>
-          </a:prstGeom>
-          <a:noFill/>
-        </p:spPr>
-        <p:txBody>
-          <a:bodyPr wrap="square" lIns="0" tIns="0" rIns="0" bIns="0" anchor="t">
-            <a:spAutoFit/>
-          </a:bodyPr>
-          <a:lstStyle/>
-          <a:p>
-            <a:pPr algn="l"/>
-            <a:r>
-              <a:rPr sz="1100" b="1" spc="200">
-                <a:solidFill>
-                  <a:srgbClr val="60C7F0"/>
-                </a:solidFill>
-                <a:latin typeface="Helvetica Neue"/>
-              </a:rPr>
-              <a:t>INSIDE SNOWFLAKE</a:t>
-            </a:r>
-          </a:p>
-        </p:txBody>
-      </p:sp>
-      <p:sp>
-        <p:nvSpPr>
-          <p:cNvPr id="34" name="TextBox 33"/>
-          <p:cNvSpPr txBox="1"/>
-          <p:nvPr/>
-        </p:nvSpPr>
-        <p:spPr>
-          <a:xfrm>
-            <a:off x="6949440" y="3172968"/>
-            <a:ext cx="4465015" cy="274320"/>
-          </a:xfrm>
-          <a:prstGeom prst="rect">
-            <a:avLst/>
-          </a:prstGeom>
-          <a:noFill/>
-        </p:spPr>
-        <p:txBody>
-          <a:bodyPr wrap="square" lIns="0" tIns="0" rIns="0" bIns="0" anchor="t">
-            <a:spAutoFit/>
-          </a:bodyPr>
-          <a:lstStyle/>
-          <a:p>
-            <a:pPr algn="r"/>
-            <a:r>
-              <a:rPr sz="1100" b="0">
-                <a:solidFill>
-                  <a:srgbClr val="A8BBCD"/>
-                </a:solidFill>
-                <a:latin typeface="Helvetica Neue"/>
-              </a:rPr>
-              <a:t>Cortex agents in AGENTSHIELD_DB.ORCH</a:t>
-            </a:r>
-          </a:p>
-        </p:txBody>
-      </p:sp>
-      <p:sp>
-        <p:nvSpPr>
-          <p:cNvPr id="35" name="Rectangle 34"/>
+          <p:cNvPr id="76" name="Rectangle 75"/>
           <p:cNvSpPr/>
           <p:nvPr/>
         </p:nvSpPr>
         <p:spPr>
           <a:xfrm>
-            <a:off x="777240" y="3547872"/>
+            <a:off x="777240" y="6263640"/>
             <a:ext cx="10637215" cy="13716"/>
           </a:xfrm>
           <a:prstGeom prst="rect">
@@ -7232,14 +7162,14 @@
       </p:sp>
       <p:sp>
         <p:nvSpPr>
-          <p:cNvPr id="36" name="Rectangle 35"/>
+          <p:cNvPr id="77" name="Rectangle 76"/>
           <p:cNvSpPr/>
           <p:nvPr/>
         </p:nvSpPr>
         <p:spPr>
           <a:xfrm>
-            <a:off x="777240" y="3536899"/>
-            <a:ext cx="1005840" cy="36576"/>
+            <a:off x="777240" y="6252667"/>
+            <a:ext cx="1097280" cy="36576"/>
           </a:xfrm>
           <a:prstGeom prst="rect">
             <a:avLst/>
@@ -7277,18 +7207,431 @@
       </p:sp>
       <p:sp>
         <p:nvSpPr>
-          <p:cNvPr id="37" name="Rounded Rectangle 36"/>
+          <p:cNvPr id="78" name="TextBox 77"/>
+          <p:cNvSpPr txBox="1"/>
+          <p:nvPr/>
+        </p:nvSpPr>
+        <p:spPr>
+          <a:xfrm>
+            <a:off x="777240" y="6382512"/>
+            <a:ext cx="5486400" cy="274320"/>
+          </a:xfrm>
+          <a:prstGeom prst="rect">
+            <a:avLst/>
+          </a:prstGeom>
+          <a:noFill/>
+        </p:spPr>
+        <p:txBody>
+          <a:bodyPr wrap="square" lIns="0" tIns="0" rIns="0" bIns="0" anchor="t">
+            <a:spAutoFit/>
+          </a:bodyPr>
+          <a:lstStyle/>
+          <a:p>
+            <a:pPr algn="l"/>
+            <a:r>
+              <a:rPr sz="1000" b="0" spc="100">
+                <a:solidFill>
+                  <a:srgbClr val="A8BBCD"/>
+                </a:solidFill>
+                <a:latin typeface="Helvetica Neue"/>
+              </a:rPr>
+              <a:t>SAVED CASES  ·  REAL EXECUTION  ·  HUMAN APPROVAL</a:t>
+            </a:r>
+          </a:p>
+        </p:txBody>
+      </p:sp>
+      <p:cxnSp>
+        <p:nvCxnSpPr>
+          <p:cNvPr id="79" name="Connector 78"/>
+          <p:cNvCxnSpPr/>
+          <p:nvPr/>
+        </p:nvCxnSpPr>
+        <p:spPr>
+          <a:xfrm>
+            <a:off x="4709160" y="2935224"/>
+            <a:ext cx="0" cy="310896"/>
+          </a:xfrm>
+          <a:prstGeom prst="line">
+            <a:avLst/>
+          </a:prstGeom>
+          <a:ln w="17780">
+            <a:solidFill>
+              <a:srgbClr val="B9A8FF"/>
+            </a:solidFill>
+          </a:ln>
+        </p:spPr>
+        <p:style>
+          <a:lnRef idx="2">
+            <a:schemeClr val="accent1"/>
+          </a:lnRef>
+          <a:fillRef idx="0">
+            <a:schemeClr val="accent1"/>
+          </a:fillRef>
+          <a:effectRef idx="1">
+            <a:schemeClr val="accent1"/>
+          </a:effectRef>
+          <a:fontRef idx="minor">
+            <a:schemeClr val="tx1"/>
+          </a:fontRef>
+        </p:style>
+      </p:cxnSp>
+      <p:cxnSp>
+        <p:nvCxnSpPr>
+          <p:cNvPr id="80" name="Connector 79"/>
+          <p:cNvCxnSpPr/>
+          <p:nvPr/>
+        </p:nvCxnSpPr>
+        <p:spPr>
+          <a:xfrm flipH="1">
+            <a:off x="2258568" y="3246120"/>
+            <a:ext cx="2450592" cy="0"/>
+          </a:xfrm>
+          <a:prstGeom prst="line">
+            <a:avLst/>
+          </a:prstGeom>
+          <a:ln w="17780">
+            <a:solidFill>
+              <a:srgbClr val="B9A8FF"/>
+            </a:solidFill>
+          </a:ln>
+        </p:spPr>
+        <p:style>
+          <a:lnRef idx="2">
+            <a:schemeClr val="accent1"/>
+          </a:lnRef>
+          <a:fillRef idx="0">
+            <a:schemeClr val="accent1"/>
+          </a:fillRef>
+          <a:effectRef idx="1">
+            <a:schemeClr val="accent1"/>
+          </a:effectRef>
+          <a:fontRef idx="minor">
+            <a:schemeClr val="tx1"/>
+          </a:fontRef>
+        </p:style>
+      </p:cxnSp>
+      <p:cxnSp>
+        <p:nvCxnSpPr>
+          <p:cNvPr id="81" name="Connector 80"/>
+          <p:cNvCxnSpPr/>
+          <p:nvPr/>
+        </p:nvCxnSpPr>
+        <p:spPr>
+          <a:xfrm>
+            <a:off x="2258568" y="3246120"/>
+            <a:ext cx="0" cy="2738628"/>
+          </a:xfrm>
+          <a:prstGeom prst="line">
+            <a:avLst/>
+          </a:prstGeom>
+          <a:ln w="17780">
+            <a:solidFill>
+              <a:srgbClr val="B9A8FF"/>
+            </a:solidFill>
+          </a:ln>
+        </p:spPr>
+        <p:style>
+          <a:lnRef idx="2">
+            <a:schemeClr val="accent1"/>
+          </a:lnRef>
+          <a:fillRef idx="0">
+            <a:schemeClr val="accent1"/>
+          </a:fillRef>
+          <a:effectRef idx="1">
+            <a:schemeClr val="accent1"/>
+          </a:effectRef>
+          <a:fontRef idx="minor">
+            <a:schemeClr val="tx1"/>
+          </a:fontRef>
+        </p:style>
+      </p:cxnSp>
+      <p:sp>
+        <p:nvSpPr>
+          <p:cNvPr id="82" name="TextBox 81"/>
+          <p:cNvSpPr txBox="1"/>
+          <p:nvPr/>
+        </p:nvSpPr>
+        <p:spPr>
+          <a:xfrm>
+            <a:off x="2395728" y="3291840"/>
+            <a:ext cx="2286000" cy="182880"/>
+          </a:xfrm>
+          <a:prstGeom prst="rect">
+            <a:avLst/>
+          </a:prstGeom>
+          <a:noFill/>
+        </p:spPr>
+        <p:txBody>
+          <a:bodyPr wrap="square" lIns="0" rIns="0" tIns="0" bIns="0" anchor="ctr">
+            <a:spAutoFit/>
+          </a:bodyPr>
+          <a:lstStyle/>
+          <a:p>
+            <a:pPr algn="l">
+              <a:spcAft>
+                <a:spcPts val="0"/>
+              </a:spcAft>
+            </a:pPr>
+            <a:r>
+              <a:rPr sz="850" b="0">
+                <a:solidFill>
+                  <a:srgbClr val="B9A8FF"/>
+                </a:solidFill>
+                <a:latin typeface="Helvetica Neue"/>
+              </a:rPr>
+              <a:t>launch campaign  ·  AGENTSHIELD_DB.ORCH</a:t>
+            </a:r>
+          </a:p>
+        </p:txBody>
+      </p:sp>
+      <p:sp>
+        <p:nvSpPr>
+          <p:cNvPr id="83" name="TextBox 82"/>
+          <p:cNvSpPr txBox="1"/>
+          <p:nvPr/>
+        </p:nvSpPr>
+        <p:spPr>
+          <a:xfrm>
+            <a:off x="777240" y="3621024"/>
+            <a:ext cx="1280160" cy="256032"/>
+          </a:xfrm>
+          <a:prstGeom prst="rect">
+            <a:avLst/>
+          </a:prstGeom>
+          <a:noFill/>
+        </p:spPr>
+        <p:txBody>
+          <a:bodyPr wrap="square" lIns="0" rIns="0" tIns="0" bIns="0" anchor="ctr">
+            <a:spAutoFit/>
+          </a:bodyPr>
+          <a:lstStyle/>
+          <a:p>
+            <a:pPr algn="l">
+              <a:spcAft>
+                <a:spcPts val="0"/>
+              </a:spcAft>
+            </a:pPr>
+            <a:r>
+              <a:rPr sz="1000" b="1">
+                <a:solidFill>
+                  <a:srgbClr val="60C7F0"/>
+                </a:solidFill>
+                <a:latin typeface="Helvetica Neue"/>
+              </a:rPr>
+              <a:t>REFERENCE INPUT</a:t>
+            </a:r>
+          </a:p>
+        </p:txBody>
+      </p:sp>
+      <p:sp>
+        <p:nvSpPr>
+          <p:cNvPr id="84" name="TextBox 83"/>
+          <p:cNvSpPr txBox="1"/>
+          <p:nvPr/>
+        </p:nvSpPr>
+        <p:spPr>
+          <a:xfrm>
+            <a:off x="2514600" y="3621024"/>
+            <a:ext cx="2468880" cy="256032"/>
+          </a:xfrm>
+          <a:prstGeom prst="rect">
+            <a:avLst/>
+          </a:prstGeom>
+          <a:noFill/>
+        </p:spPr>
+        <p:txBody>
+          <a:bodyPr wrap="square" lIns="0" rIns="0" tIns="0" bIns="0" anchor="ctr">
+            <a:spAutoFit/>
+          </a:bodyPr>
+          <a:lstStyle/>
+          <a:p>
+            <a:pPr algn="l">
+              <a:spcAft>
+                <a:spcPts val="0"/>
+              </a:spcAft>
+            </a:pPr>
+            <a:r>
+              <a:rPr sz="1100" b="1">
+                <a:solidFill>
+                  <a:srgbClr val="B9A8FF"/>
+                </a:solidFill>
+                <a:latin typeface="Helvetica Neue"/>
+              </a:rPr>
+              <a:t>8 SPECIALIST AGENTS</a:t>
+            </a:r>
+          </a:p>
+        </p:txBody>
+      </p:sp>
+      <p:sp>
+        <p:nvSpPr>
+          <p:cNvPr id="85" name="TextBox 84"/>
+          <p:cNvSpPr txBox="1"/>
+          <p:nvPr/>
+        </p:nvSpPr>
+        <p:spPr>
+          <a:xfrm>
+            <a:off x="2514600" y="3840480"/>
+            <a:ext cx="2468880" cy="146304"/>
+          </a:xfrm>
+          <a:prstGeom prst="rect">
+            <a:avLst/>
+          </a:prstGeom>
+          <a:noFill/>
+        </p:spPr>
+        <p:txBody>
+          <a:bodyPr wrap="square" lIns="0" rIns="0" tIns="0" bIns="0" anchor="ctr">
+            <a:spAutoFit/>
+          </a:bodyPr>
+          <a:lstStyle/>
+          <a:p>
+            <a:pPr algn="l">
+              <a:spcAft>
+                <a:spcPts val="0"/>
+              </a:spcAft>
+            </a:pPr>
+            <a:r>
+              <a:rPr sz="850" b="0">
+                <a:solidFill>
+                  <a:srgbClr val="A8BBCD"/>
+                </a:solidFill>
+                <a:latin typeface="Helvetica Neue"/>
+              </a:rPr>
+              <a:t>Generate and save category test cases</a:t>
+            </a:r>
+          </a:p>
+        </p:txBody>
+      </p:sp>
+      <p:sp>
+        <p:nvSpPr>
+          <p:cNvPr id="86" name="TextBox 85"/>
+          <p:cNvSpPr txBox="1"/>
+          <p:nvPr/>
+        </p:nvSpPr>
+        <p:spPr>
+          <a:xfrm>
+            <a:off x="5376672" y="3621024"/>
+            <a:ext cx="1737360" cy="256032"/>
+          </a:xfrm>
+          <a:prstGeom prst="rect">
+            <a:avLst/>
+          </a:prstGeom>
+          <a:noFill/>
+        </p:spPr>
+        <p:txBody>
+          <a:bodyPr wrap="square" lIns="0" rIns="0" tIns="0" bIns="0" anchor="ctr">
+            <a:spAutoFit/>
+          </a:bodyPr>
+          <a:lstStyle/>
+          <a:p>
+            <a:pPr algn="l">
+              <a:spcAft>
+                <a:spcPts val="0"/>
+              </a:spcAft>
+            </a:pPr>
+            <a:r>
+              <a:rPr sz="1000" b="1">
+                <a:solidFill>
+                  <a:srgbClr val="60C7F0"/>
+                </a:solidFill>
+                <a:latin typeface="Helvetica Neue"/>
+              </a:rPr>
+              <a:t>LIVE EXECUTION</a:t>
+            </a:r>
+          </a:p>
+        </p:txBody>
+      </p:sp>
+      <p:sp>
+        <p:nvSpPr>
+          <p:cNvPr id="87" name="TextBox 86"/>
+          <p:cNvSpPr txBox="1"/>
+          <p:nvPr/>
+        </p:nvSpPr>
+        <p:spPr>
+          <a:xfrm>
+            <a:off x="7406640" y="3621024"/>
+            <a:ext cx="914400" cy="256032"/>
+          </a:xfrm>
+          <a:prstGeom prst="rect">
+            <a:avLst/>
+          </a:prstGeom>
+          <a:noFill/>
+        </p:spPr>
+        <p:txBody>
+          <a:bodyPr wrap="square" lIns="0" rIns="0" tIns="0" bIns="0" anchor="ctr">
+            <a:spAutoFit/>
+          </a:bodyPr>
+          <a:lstStyle/>
+          <a:p>
+            <a:pPr algn="l">
+              <a:spcAft>
+                <a:spcPts val="0"/>
+              </a:spcAft>
+            </a:pPr>
+            <a:r>
+              <a:rPr sz="1000" b="1">
+                <a:solidFill>
+                  <a:srgbClr val="60C7F0"/>
+                </a:solidFill>
+                <a:latin typeface="Helvetica Neue"/>
+              </a:rPr>
+              <a:t>RESULTS</a:t>
+            </a:r>
+          </a:p>
+        </p:txBody>
+      </p:sp>
+      <p:sp>
+        <p:nvSpPr>
+          <p:cNvPr id="88" name="TextBox 87"/>
+          <p:cNvSpPr txBox="1"/>
+          <p:nvPr/>
+        </p:nvSpPr>
+        <p:spPr>
+          <a:xfrm>
+            <a:off x="9710928" y="3621024"/>
+            <a:ext cx="1645920" cy="256032"/>
+          </a:xfrm>
+          <a:prstGeom prst="rect">
+            <a:avLst/>
+          </a:prstGeom>
+          <a:noFill/>
+        </p:spPr>
+        <p:txBody>
+          <a:bodyPr wrap="square" lIns="0" rIns="0" tIns="0" bIns="0" anchor="ctr">
+            <a:spAutoFit/>
+          </a:bodyPr>
+          <a:lstStyle/>
+          <a:p>
+            <a:pPr algn="l">
+              <a:spcAft>
+                <a:spcPts val="0"/>
+              </a:spcAft>
+            </a:pPr>
+            <a:r>
+              <a:rPr sz="1000" b="1">
+                <a:solidFill>
+                  <a:srgbClr val="61D2BD"/>
+                </a:solidFill>
+                <a:latin typeface="Helvetica Neue"/>
+              </a:rPr>
+              <a:t>FIXES</a:t>
+            </a:r>
+          </a:p>
+        </p:txBody>
+      </p:sp>
+      <p:sp>
+        <p:nvSpPr>
+          <p:cNvPr id="89" name="Rounded Rectangle 88"/>
           <p:cNvSpPr/>
           <p:nvPr/>
         </p:nvSpPr>
         <p:spPr>
           <a:xfrm>
-            <a:off x="777240" y="3776472"/>
-            <a:ext cx="1874519" cy="2194560"/>
+            <a:off x="777240" y="4315968"/>
+            <a:ext cx="1280160" cy="1353312"/>
           </a:xfrm>
           <a:prstGeom prst="roundRect">
             <a:avLst>
-              <a:gd name="adj" fmla="val 6000"/>
+              <a:gd name="adj" fmla="val 10000"/>
             </a:avLst>
           </a:prstGeom>
           <a:solidFill>
@@ -7296,7 +7639,7 @@
           </a:solidFill>
           <a:ln w="12700">
             <a:solidFill>
-              <a:srgbClr val="304459"/>
+              <a:srgbClr val="60C7F0"/>
             </a:solidFill>
           </a:ln>
           <a:effectLst/>
@@ -7320,20 +7663,19 @@
           <a:lstStyle/>
           <a:p>
             <a:pPr algn="ctr"/>
-            <a:endParaRPr/>
-          </a:p>
-        </p:txBody>
-      </p:sp>
-      <p:sp>
-        <p:nvSpPr>
-          <p:cNvPr id="38" name="TextBox 37"/>
+          </a:p>
+        </p:txBody>
+      </p:sp>
+      <p:sp>
+        <p:nvSpPr>
+          <p:cNvPr id="90" name="TextBox 89"/>
           <p:cNvSpPr txBox="1"/>
           <p:nvPr/>
         </p:nvSpPr>
         <p:spPr>
           <a:xfrm>
-            <a:off x="941832" y="3941063"/>
-            <a:ext cx="1545336" cy="274320"/>
+            <a:off x="822960" y="4416552"/>
+            <a:ext cx="1188720" cy="329184"/>
           </a:xfrm>
           <a:prstGeom prst="rect">
             <a:avLst/>
@@ -7341,51 +7683,20 @@
           <a:noFill/>
         </p:spPr>
         <p:txBody>
-          <a:bodyPr wrap="square" lIns="0" tIns="0" rIns="0" bIns="0" anchor="t">
+          <a:bodyPr wrap="square" lIns="0" rIns="0" tIns="0" bIns="0" anchor="ctr">
             <a:spAutoFit/>
           </a:bodyPr>
           <a:lstStyle/>
           <a:p>
-            <a:pPr algn="l"/>
-            <a:r>
-              <a:rPr sz="1500" b="1">
+            <a:pPr algn="ctr">
+              <a:spcAft>
+                <a:spcPts val="0"/>
+              </a:spcAft>
+            </a:pPr>
+            <a:r>
+              <a:rPr sz="2400" b="1">
                 <a:solidFill>
-                  <a:srgbClr val="29B5E8"/>
-                </a:solidFill>
-                <a:latin typeface="Helvetica Neue"/>
-              </a:rPr>
-              <a:t>Reference library</a:t>
-            </a:r>
-          </a:p>
-        </p:txBody>
-      </p:sp>
-      <p:sp>
-        <p:nvSpPr>
-          <p:cNvPr id="39" name="TextBox 38"/>
-          <p:cNvSpPr txBox="1"/>
-          <p:nvPr/>
-        </p:nvSpPr>
-        <p:spPr>
-          <a:xfrm>
-            <a:off x="941832" y="4407408"/>
-            <a:ext cx="1554480" cy="502920"/>
-          </a:xfrm>
-          <a:prstGeom prst="rect">
-            <a:avLst/>
-          </a:prstGeom>
-          <a:noFill/>
-        </p:spPr>
-        <p:txBody>
-          <a:bodyPr wrap="square" lIns="0" tIns="0" rIns="0" bIns="0" anchor="t">
-            <a:spAutoFit/>
-          </a:bodyPr>
-          <a:lstStyle/>
-          <a:p>
-            <a:pPr algn="l"/>
-            <a:r>
-              <a:rPr sz="3400" b="1">
-                <a:solidFill>
-                  <a:srgbClr val="29B5E8"/>
+                  <a:srgbClr val="60C7F0"/>
                 </a:solidFill>
                 <a:latin typeface="Helvetica Neue"/>
               </a:rPr>
@@ -7396,14 +7707,14 @@
       </p:sp>
       <p:sp>
         <p:nvSpPr>
-          <p:cNvPr id="40" name="TextBox 39"/>
+          <p:cNvPr id="91" name="TextBox 90"/>
           <p:cNvSpPr txBox="1"/>
           <p:nvPr/>
         </p:nvSpPr>
         <p:spPr>
           <a:xfrm>
-            <a:off x="941832" y="4956048"/>
-            <a:ext cx="1554480" cy="594360"/>
+            <a:off x="804672" y="4773168"/>
+            <a:ext cx="1225296" cy="539496"/>
           </a:xfrm>
           <a:prstGeom prst="rect">
             <a:avLst/>
@@ -7411,35 +7722,70 @@
           <a:noFill/>
         </p:spPr>
         <p:txBody>
-          <a:bodyPr wrap="square" lIns="0" tIns="0" rIns="0" bIns="0" anchor="t">
+          <a:bodyPr wrap="square" lIns="0" rIns="0" tIns="0" bIns="0" anchor="ctr">
             <a:spAutoFit/>
           </a:bodyPr>
           <a:lstStyle/>
           <a:p>
-            <a:pPr algn="l"/>
-            <a:r>
-              <a:rPr sz="1200" b="0">
+            <a:pPr algn="ctr">
+              <a:spcAft>
+                <a:spcPts val="0"/>
+              </a:spcAft>
+            </a:pPr>
+            <a:r>
+              <a:rPr sz="950" b="0">
                 <a:solidFill>
                   <a:srgbClr val="A8BBCD"/>
                 </a:solidFill>
                 <a:latin typeface="Helvetica Neue"/>
               </a:rPr>
-              <a:t>15 templates per category
-+ 1 benign baseline</a:t>
-            </a:r>
-          </a:p>
-        </p:txBody>
-      </p:sp>
-      <p:sp>
-        <p:nvSpPr>
-          <p:cNvPr id="41" name="TextBox 40"/>
+              <a:t>reference templates</a:t>
+            </a:r>
+          </a:p>
+          <a:p>
+            <a:pPr algn="ctr">
+              <a:spcAft>
+                <a:spcPts val="0"/>
+              </a:spcAft>
+            </a:pPr>
+            <a:r>
+              <a:rPr sz="950" b="0">
+                <a:solidFill>
+                  <a:srgbClr val="A8BBCD"/>
+                </a:solidFill>
+                <a:latin typeface="Helvetica Neue"/>
+              </a:rPr>
+              <a:t>15 per category</a:t>
+            </a:r>
+          </a:p>
+          <a:p>
+            <a:pPr algn="ctr">
+              <a:spcAft>
+                <a:spcPts val="0"/>
+              </a:spcAft>
+            </a:pPr>
+            <a:r>
+              <a:rPr sz="950" b="0">
+                <a:solidFill>
+                  <a:srgbClr val="A8BBCD"/>
+                </a:solidFill>
+                <a:latin typeface="Helvetica Neue"/>
+              </a:rPr>
+              <a:t>+ 1 baseline</a:t>
+            </a:r>
+          </a:p>
+        </p:txBody>
+      </p:sp>
+      <p:sp>
+        <p:nvSpPr>
+          <p:cNvPr id="92" name="TextBox 91"/>
           <p:cNvSpPr txBox="1"/>
           <p:nvPr/>
         </p:nvSpPr>
         <p:spPr>
           <a:xfrm>
-            <a:off x="941832" y="5623560"/>
-            <a:ext cx="1554480" cy="210312"/>
+            <a:off x="804672" y="5385816"/>
+            <a:ext cx="1225296" cy="164592"/>
           </a:xfrm>
           <a:prstGeom prst="rect">
             <a:avLst/>
@@ -7447,16 +7793,20 @@
           <a:noFill/>
         </p:spPr>
         <p:txBody>
-          <a:bodyPr wrap="square" lIns="0" tIns="0" rIns="0" bIns="0" anchor="t">
+          <a:bodyPr wrap="square" lIns="0" rIns="0" tIns="0" bIns="0" anchor="ctr">
             <a:spAutoFit/>
           </a:bodyPr>
           <a:lstStyle/>
           <a:p>
-            <a:pPr algn="l"/>
-            <a:r>
-              <a:rPr sz="950" b="1">
+            <a:pPr algn="ctr">
+              <a:spcAft>
+                <a:spcPts val="0"/>
+              </a:spcAft>
+            </a:pPr>
+            <a:r>
+              <a:rPr sz="780" b="0">
                 <a:solidFill>
-                  <a:srgbClr val="EDF5FF"/>
+                  <a:srgbClr val="A8BBCD"/>
                 </a:solidFill>
                 <a:latin typeface="Helvetica Neue"/>
               </a:rPr>
@@ -7465,532 +7815,165 @@
           </a:p>
         </p:txBody>
       </p:sp>
-      <p:sp>
-        <p:nvSpPr>
-          <p:cNvPr id="42" name="Rounded Rectangle 41"/>
+      <p:cxnSp>
+        <p:nvCxnSpPr>
+          <p:cNvPr id="93" name="Connector 92"/>
+          <p:cNvCxnSpPr/>
+          <p:nvPr/>
+        </p:nvCxnSpPr>
+        <p:spPr>
+          <a:xfrm>
+            <a:off x="2057400" y="4901184"/>
+            <a:ext cx="201168" cy="0"/>
+          </a:xfrm>
+          <a:prstGeom prst="line">
+            <a:avLst/>
+          </a:prstGeom>
+          <a:ln w="17780">
+            <a:solidFill>
+              <a:srgbClr val="60C7F0"/>
+            </a:solidFill>
+          </a:ln>
+        </p:spPr>
+        <p:style>
+          <a:lnRef idx="2">
+            <a:schemeClr val="accent1"/>
+          </a:lnRef>
+          <a:fillRef idx="0">
+            <a:schemeClr val="accent1"/>
+          </a:fillRef>
+          <a:effectRef idx="1">
+            <a:schemeClr val="accent1"/>
+          </a:effectRef>
+          <a:fontRef idx="minor">
+            <a:schemeClr val="tx1"/>
+          </a:fontRef>
+        </p:style>
+      </p:cxnSp>
+      <p:cxnSp>
+        <p:nvCxnSpPr>
+          <p:cNvPr id="94" name="Connector 93"/>
+          <p:cNvCxnSpPr/>
+          <p:nvPr/>
+        </p:nvCxnSpPr>
+        <p:spPr>
+          <a:xfrm>
+            <a:off x="5212080" y="4128515"/>
+            <a:ext cx="0" cy="1856233"/>
+          </a:xfrm>
+          <a:prstGeom prst="line">
+            <a:avLst/>
+          </a:prstGeom>
+          <a:ln w="17780">
+            <a:solidFill>
+              <a:srgbClr val="B9A8FF"/>
+            </a:solidFill>
+          </a:ln>
+        </p:spPr>
+        <p:style>
+          <a:lnRef idx="2">
+            <a:schemeClr val="accent1"/>
+          </a:lnRef>
+          <a:fillRef idx="0">
+            <a:schemeClr val="accent1"/>
+          </a:fillRef>
+          <a:effectRef idx="1">
+            <a:schemeClr val="accent1"/>
+          </a:effectRef>
+          <a:fontRef idx="minor">
+            <a:schemeClr val="tx1"/>
+          </a:fontRef>
+        </p:style>
+      </p:cxnSp>
+      <p:cxnSp>
+        <p:nvCxnSpPr>
+          <p:cNvPr id="95" name="Connector 94"/>
+          <p:cNvCxnSpPr/>
+          <p:nvPr/>
+        </p:nvCxnSpPr>
+        <p:spPr>
+          <a:xfrm>
+            <a:off x="2258568" y="4128516"/>
+            <a:ext cx="256032" cy="0"/>
+          </a:xfrm>
+          <a:prstGeom prst="line">
+            <a:avLst/>
+          </a:prstGeom>
+          <a:ln w="17780">
+            <a:solidFill>
+              <a:srgbClr val="B9A8FF"/>
+            </a:solidFill>
+            <a:tailEnd type="triangle"/>
+          </a:ln>
+        </p:spPr>
+        <p:style>
+          <a:lnRef idx="2">
+            <a:schemeClr val="accent1"/>
+          </a:lnRef>
+          <a:fillRef idx="0">
+            <a:schemeClr val="accent1"/>
+          </a:fillRef>
+          <a:effectRef idx="1">
+            <a:schemeClr val="accent1"/>
+          </a:effectRef>
+          <a:fontRef idx="minor">
+            <a:schemeClr val="tx1"/>
+          </a:fontRef>
+        </p:style>
+      </p:cxnSp>
+      <p:cxnSp>
+        <p:nvCxnSpPr>
+          <p:cNvPr id="96" name="Connector 95"/>
+          <p:cNvCxnSpPr/>
+          <p:nvPr/>
+        </p:nvCxnSpPr>
+        <p:spPr>
+          <a:xfrm>
+            <a:off x="4983480" y="4128516"/>
+            <a:ext cx="228600" cy="0"/>
+          </a:xfrm>
+          <a:prstGeom prst="line">
+            <a:avLst/>
+          </a:prstGeom>
+          <a:ln w="17780">
+            <a:solidFill>
+              <a:srgbClr val="B9A8FF"/>
+            </a:solidFill>
+          </a:ln>
+        </p:spPr>
+        <p:style>
+          <a:lnRef idx="2">
+            <a:schemeClr val="accent1"/>
+          </a:lnRef>
+          <a:fillRef idx="0">
+            <a:schemeClr val="accent1"/>
+          </a:fillRef>
+          <a:effectRef idx="1">
+            <a:schemeClr val="accent1"/>
+          </a:effectRef>
+          <a:fontRef idx="minor">
+            <a:schemeClr val="tx1"/>
+          </a:fontRef>
+        </p:style>
+      </p:cxnSp>
+      <p:sp>
+        <p:nvSpPr>
+          <p:cNvPr id="97" name="Rounded Rectangle 96"/>
           <p:cNvSpPr/>
           <p:nvPr/>
         </p:nvSpPr>
         <p:spPr>
           <a:xfrm>
-            <a:off x="2926080" y="3776472"/>
-            <a:ext cx="3429000" cy="2194560"/>
+            <a:off x="2514600" y="4023360"/>
+            <a:ext cx="2468880" cy="210312"/>
           </a:xfrm>
           <a:prstGeom prst="roundRect">
             <a:avLst>
-              <a:gd name="adj" fmla="val 6000"/>
+              <a:gd name="adj" fmla="val 10000"/>
             </a:avLst>
           </a:prstGeom>
           <a:solidFill>
             <a:srgbClr val="122132"/>
-          </a:solidFill>
-          <a:ln w="12700">
-            <a:solidFill>
-              <a:srgbClr val="304459"/>
-            </a:solidFill>
-          </a:ln>
-          <a:effectLst/>
-        </p:spPr>
-        <p:style>
-          <a:lnRef idx="1">
-            <a:schemeClr val="accent1"/>
-          </a:lnRef>
-          <a:fillRef idx="3">
-            <a:schemeClr val="accent1"/>
-          </a:fillRef>
-          <a:effectRef idx="2">
-            <a:schemeClr val="accent1"/>
-          </a:effectRef>
-          <a:fontRef idx="minor">
-            <a:schemeClr val="lt1"/>
-          </a:fontRef>
-        </p:style>
-        <p:txBody>
-          <a:bodyPr rtlCol="0" anchor="ctr"/>
-          <a:lstStyle/>
-          <a:p>
-            <a:pPr algn="ctr"/>
-            <a:endParaRPr dirty="0"/>
-          </a:p>
-        </p:txBody>
-      </p:sp>
-      <p:sp>
-        <p:nvSpPr>
-          <p:cNvPr id="43" name="TextBox 42"/>
-          <p:cNvSpPr txBox="1"/>
-          <p:nvPr/>
-        </p:nvSpPr>
-        <p:spPr>
-          <a:xfrm>
-            <a:off x="3090672" y="3941063"/>
-            <a:ext cx="3099816" cy="461665"/>
-          </a:xfrm>
-          <a:prstGeom prst="rect">
-            <a:avLst/>
-          </a:prstGeom>
-          <a:noFill/>
-        </p:spPr>
-        <p:txBody>
-          <a:bodyPr wrap="square" lIns="0" tIns="0" rIns="0" bIns="0" anchor="t">
-            <a:spAutoFit/>
-          </a:bodyPr>
-          <a:lstStyle/>
-          <a:p>
-            <a:pPr algn="l"/>
-            <a:r>
-              <a:rPr sz="1500" b="1" dirty="0">
-                <a:solidFill>
-                  <a:srgbClr val="B9A8FF"/>
-                </a:solidFill>
-                <a:latin typeface="Helvetica Neue"/>
-              </a:rPr>
-              <a:t>8 specialist</a:t>
-            </a:r>
-            <a:r>
-              <a:rPr lang="en-US" sz="1500" b="1" dirty="0">
-                <a:solidFill>
-                  <a:srgbClr val="B9A8FF"/>
-                </a:solidFill>
-                <a:latin typeface="Helvetica Neue"/>
-              </a:rPr>
-              <a:t> agents across 8 attack categories</a:t>
-            </a:r>
-            <a:endParaRPr sz="1500" b="1" dirty="0">
-              <a:solidFill>
-                <a:srgbClr val="B9A8FF"/>
-              </a:solidFill>
-              <a:latin typeface="Helvetica Neue"/>
-            </a:endParaRPr>
-          </a:p>
-        </p:txBody>
-      </p:sp>
-      <p:sp>
-        <p:nvSpPr>
-          <p:cNvPr id="44" name="TextBox 43"/>
-          <p:cNvSpPr txBox="1"/>
-          <p:nvPr/>
-        </p:nvSpPr>
-        <p:spPr>
-          <a:xfrm>
-            <a:off x="3090672" y="4475883"/>
-            <a:ext cx="1572768" cy="201168"/>
-          </a:xfrm>
-          <a:prstGeom prst="rect">
-            <a:avLst/>
-          </a:prstGeom>
-          <a:noFill/>
-        </p:spPr>
-        <p:txBody>
-          <a:bodyPr wrap="square" lIns="0" tIns="0" rIns="0" bIns="0" anchor="t">
-            <a:spAutoFit/>
-          </a:bodyPr>
-          <a:lstStyle/>
-          <a:p>
-            <a:pPr algn="l"/>
-            <a:r>
-              <a:rPr sz="910" b="0" dirty="0">
-                <a:solidFill>
-                  <a:srgbClr val="EDF5FF"/>
-                </a:solidFill>
-                <a:latin typeface="Helvetica Neue"/>
-              </a:rPr>
-              <a:t>PROMPT_INJECTION</a:t>
-            </a:r>
-          </a:p>
-        </p:txBody>
-      </p:sp>
-      <p:sp>
-        <p:nvSpPr>
-          <p:cNvPr id="45" name="TextBox 44"/>
-          <p:cNvSpPr txBox="1"/>
-          <p:nvPr/>
-        </p:nvSpPr>
-        <p:spPr>
-          <a:xfrm>
-            <a:off x="4663440" y="4475883"/>
-            <a:ext cx="1572768" cy="201168"/>
-          </a:xfrm>
-          <a:prstGeom prst="rect">
-            <a:avLst/>
-          </a:prstGeom>
-          <a:noFill/>
-        </p:spPr>
-        <p:txBody>
-          <a:bodyPr wrap="square" lIns="0" tIns="0" rIns="0" bIns="0" anchor="t">
-            <a:spAutoFit/>
-          </a:bodyPr>
-          <a:lstStyle/>
-          <a:p>
-            <a:pPr algn="l"/>
-            <a:r>
-              <a:rPr sz="910" b="0">
-                <a:solidFill>
-                  <a:srgbClr val="EDF5FF"/>
-                </a:solidFill>
-                <a:latin typeface="Helvetica Neue"/>
-              </a:rPr>
-              <a:t>PII_EXTRACTION</a:t>
-            </a:r>
-          </a:p>
-        </p:txBody>
-      </p:sp>
-      <p:sp>
-        <p:nvSpPr>
-          <p:cNvPr id="46" name="TextBox 45"/>
-          <p:cNvSpPr txBox="1"/>
-          <p:nvPr/>
-        </p:nvSpPr>
-        <p:spPr>
-          <a:xfrm>
-            <a:off x="3090672" y="4713627"/>
-            <a:ext cx="1572768" cy="201168"/>
-          </a:xfrm>
-          <a:prstGeom prst="rect">
-            <a:avLst/>
-          </a:prstGeom>
-          <a:noFill/>
-        </p:spPr>
-        <p:txBody>
-          <a:bodyPr wrap="square" lIns="0" tIns="0" rIns="0" bIns="0" anchor="t">
-            <a:spAutoFit/>
-          </a:bodyPr>
-          <a:lstStyle/>
-          <a:p>
-            <a:pPr algn="l"/>
-            <a:r>
-              <a:rPr sz="910" b="0">
-                <a:solidFill>
-                  <a:srgbClr val="EDF5FF"/>
-                </a:solidFill>
-                <a:latin typeface="Helvetica Neue"/>
-              </a:rPr>
-              <a:t>SCOPE_VIOLATION</a:t>
-            </a:r>
-          </a:p>
-        </p:txBody>
-      </p:sp>
-      <p:sp>
-        <p:nvSpPr>
-          <p:cNvPr id="47" name="TextBox 46"/>
-          <p:cNvSpPr txBox="1"/>
-          <p:nvPr/>
-        </p:nvSpPr>
-        <p:spPr>
-          <a:xfrm>
-            <a:off x="4663440" y="4713627"/>
-            <a:ext cx="1572768" cy="201168"/>
-          </a:xfrm>
-          <a:prstGeom prst="rect">
-            <a:avLst/>
-          </a:prstGeom>
-          <a:noFill/>
-        </p:spPr>
-        <p:txBody>
-          <a:bodyPr wrap="square" lIns="0" tIns="0" rIns="0" bIns="0" anchor="t">
-            <a:spAutoFit/>
-          </a:bodyPr>
-          <a:lstStyle/>
-          <a:p>
-            <a:pPr algn="l"/>
-            <a:r>
-              <a:rPr sz="910" b="0">
-                <a:solidFill>
-                  <a:srgbClr val="EDF5FF"/>
-                </a:solidFill>
-                <a:latin typeface="Helvetica Neue"/>
-              </a:rPr>
-              <a:t>SOCIAL_ENGINEERING</a:t>
-            </a:r>
-          </a:p>
-        </p:txBody>
-      </p:sp>
-      <p:sp>
-        <p:nvSpPr>
-          <p:cNvPr id="48" name="TextBox 47"/>
-          <p:cNvSpPr txBox="1"/>
-          <p:nvPr/>
-        </p:nvSpPr>
-        <p:spPr>
-          <a:xfrm>
-            <a:off x="3090672" y="4951371"/>
-            <a:ext cx="1572768" cy="201168"/>
-          </a:xfrm>
-          <a:prstGeom prst="rect">
-            <a:avLst/>
-          </a:prstGeom>
-          <a:noFill/>
-        </p:spPr>
-        <p:txBody>
-          <a:bodyPr wrap="square" lIns="0" tIns="0" rIns="0" bIns="0" anchor="t">
-            <a:spAutoFit/>
-          </a:bodyPr>
-          <a:lstStyle/>
-          <a:p>
-            <a:pPr algn="l"/>
-            <a:r>
-              <a:rPr sz="910" b="0">
-                <a:solidFill>
-                  <a:srgbClr val="EDF5FF"/>
-                </a:solidFill>
-                <a:latin typeface="Helvetica Neue"/>
-              </a:rPr>
-              <a:t>MULTI_TURN</a:t>
-            </a:r>
-          </a:p>
-        </p:txBody>
-      </p:sp>
-      <p:sp>
-        <p:nvSpPr>
-          <p:cNvPr id="49" name="TextBox 48"/>
-          <p:cNvSpPr txBox="1"/>
-          <p:nvPr/>
-        </p:nvSpPr>
-        <p:spPr>
-          <a:xfrm>
-            <a:off x="4663440" y="4951371"/>
-            <a:ext cx="1572768" cy="201168"/>
-          </a:xfrm>
-          <a:prstGeom prst="rect">
-            <a:avLst/>
-          </a:prstGeom>
-          <a:noFill/>
-        </p:spPr>
-        <p:txBody>
-          <a:bodyPr wrap="square" lIns="0" tIns="0" rIns="0" bIns="0" anchor="t">
-            <a:spAutoFit/>
-          </a:bodyPr>
-          <a:lstStyle/>
-          <a:p>
-            <a:pPr algn="l"/>
-            <a:r>
-              <a:rPr sz="910" b="0" dirty="0">
-                <a:solidFill>
-                  <a:srgbClr val="EDF5FF"/>
-                </a:solidFill>
-                <a:latin typeface="Helvetica Neue"/>
-              </a:rPr>
-              <a:t>DATA_EXFILTRATION</a:t>
-            </a:r>
-          </a:p>
-        </p:txBody>
-      </p:sp>
-      <p:sp>
-        <p:nvSpPr>
-          <p:cNvPr id="50" name="TextBox 49"/>
-          <p:cNvSpPr txBox="1"/>
-          <p:nvPr/>
-        </p:nvSpPr>
-        <p:spPr>
-          <a:xfrm>
-            <a:off x="3090672" y="5189115"/>
-            <a:ext cx="1572768" cy="201168"/>
-          </a:xfrm>
-          <a:prstGeom prst="rect">
-            <a:avLst/>
-          </a:prstGeom>
-          <a:noFill/>
-        </p:spPr>
-        <p:txBody>
-          <a:bodyPr wrap="square" lIns="0" tIns="0" rIns="0" bIns="0" anchor="t">
-            <a:spAutoFit/>
-          </a:bodyPr>
-          <a:lstStyle/>
-          <a:p>
-            <a:pPr algn="l"/>
-            <a:r>
-              <a:rPr sz="910" b="0">
-                <a:solidFill>
-                  <a:srgbClr val="EDF5FF"/>
-                </a:solidFill>
-                <a:latin typeface="Helvetica Neue"/>
-              </a:rPr>
-              <a:t>ROLE_ESCALATION</a:t>
-            </a:r>
-          </a:p>
-        </p:txBody>
-      </p:sp>
-      <p:sp>
-        <p:nvSpPr>
-          <p:cNvPr id="51" name="TextBox 50"/>
-          <p:cNvSpPr txBox="1"/>
-          <p:nvPr/>
-        </p:nvSpPr>
-        <p:spPr>
-          <a:xfrm>
-            <a:off x="4663440" y="5189115"/>
-            <a:ext cx="1572768" cy="201168"/>
-          </a:xfrm>
-          <a:prstGeom prst="rect">
-            <a:avLst/>
-          </a:prstGeom>
-          <a:noFill/>
-        </p:spPr>
-        <p:txBody>
-          <a:bodyPr wrap="square" lIns="0" tIns="0" rIns="0" bIns="0" anchor="t">
-            <a:spAutoFit/>
-          </a:bodyPr>
-          <a:lstStyle/>
-          <a:p>
-            <a:pPr algn="l"/>
-            <a:r>
-              <a:rPr sz="910" b="0">
-                <a:solidFill>
-                  <a:srgbClr val="EDF5FF"/>
-                </a:solidFill>
-                <a:latin typeface="Helvetica Neue"/>
-              </a:rPr>
-              <a:t>INDIRECT_INJECTION</a:t>
-            </a:r>
-          </a:p>
-        </p:txBody>
-      </p:sp>
-      <p:sp>
-        <p:nvSpPr>
-          <p:cNvPr id="52" name="Rectangle 51"/>
-          <p:cNvSpPr/>
-          <p:nvPr/>
-        </p:nvSpPr>
-        <p:spPr>
-          <a:xfrm>
-            <a:off x="3090672" y="5468112"/>
-            <a:ext cx="3081528" cy="11887"/>
-          </a:xfrm>
-          <a:prstGeom prst="rect">
-            <a:avLst/>
-          </a:prstGeom>
-          <a:solidFill>
-            <a:srgbClr val="304459"/>
-          </a:solidFill>
-          <a:ln>
-            <a:noFill/>
-          </a:ln>
-          <a:effectLst/>
-        </p:spPr>
-        <p:style>
-          <a:lnRef idx="1">
-            <a:schemeClr val="accent1"/>
-          </a:lnRef>
-          <a:fillRef idx="3">
-            <a:schemeClr val="accent1"/>
-          </a:fillRef>
-          <a:effectRef idx="2">
-            <a:schemeClr val="accent1"/>
-          </a:effectRef>
-          <a:fontRef idx="minor">
-            <a:schemeClr val="lt1"/>
-          </a:fontRef>
-        </p:style>
-        <p:txBody>
-          <a:bodyPr rtlCol="0" anchor="ctr"/>
-          <a:lstStyle/>
-          <a:p>
-            <a:pPr algn="ctr"/>
-            <a:endParaRPr/>
-          </a:p>
-        </p:txBody>
-      </p:sp>
-      <p:sp>
-        <p:nvSpPr>
-          <p:cNvPr id="54" name="Rounded Rectangle 53"/>
-          <p:cNvSpPr/>
-          <p:nvPr/>
-        </p:nvSpPr>
-        <p:spPr>
-          <a:xfrm>
-            <a:off x="6629400" y="3776472"/>
-            <a:ext cx="2194560" cy="2194560"/>
-          </a:xfrm>
-          <a:prstGeom prst="roundRect">
-            <a:avLst>
-              <a:gd name="adj" fmla="val 6000"/>
-            </a:avLst>
-          </a:prstGeom>
-          <a:solidFill>
-            <a:srgbClr val="122132"/>
-          </a:solidFill>
-          <a:ln w="12700">
-            <a:solidFill>
-              <a:srgbClr val="304459"/>
-            </a:solidFill>
-          </a:ln>
-          <a:effectLst/>
-        </p:spPr>
-        <p:style>
-          <a:lnRef idx="1">
-            <a:schemeClr val="accent1"/>
-          </a:lnRef>
-          <a:fillRef idx="3">
-            <a:schemeClr val="accent1"/>
-          </a:fillRef>
-          <a:effectRef idx="2">
-            <a:schemeClr val="accent1"/>
-          </a:effectRef>
-          <a:fontRef idx="minor">
-            <a:schemeClr val="lt1"/>
-          </a:fontRef>
-        </p:style>
-        <p:txBody>
-          <a:bodyPr rtlCol="0" anchor="ctr"/>
-          <a:lstStyle/>
-          <a:p>
-            <a:pPr algn="ctr"/>
-            <a:endParaRPr/>
-          </a:p>
-        </p:txBody>
-      </p:sp>
-      <p:sp>
-        <p:nvSpPr>
-          <p:cNvPr id="55" name="TextBox 54"/>
-          <p:cNvSpPr txBox="1"/>
-          <p:nvPr/>
-        </p:nvSpPr>
-        <p:spPr>
-          <a:xfrm>
-            <a:off x="6793992" y="3941063"/>
-            <a:ext cx="1865376" cy="274320"/>
-          </a:xfrm>
-          <a:prstGeom prst="rect">
-            <a:avLst/>
-          </a:prstGeom>
-          <a:noFill/>
-        </p:spPr>
-        <p:txBody>
-          <a:bodyPr wrap="square" lIns="0" tIns="0" rIns="0" bIns="0" anchor="t">
-            <a:spAutoFit/>
-          </a:bodyPr>
-          <a:lstStyle/>
-          <a:p>
-            <a:pPr algn="l"/>
-            <a:r>
-              <a:rPr sz="1500" b="1">
-                <a:solidFill>
-                  <a:srgbClr val="B9A8FF"/>
-                </a:solidFill>
-                <a:latin typeface="Helvetica Neue"/>
-              </a:rPr>
-              <a:t>Parallel live tests</a:t>
-            </a:r>
-          </a:p>
-        </p:txBody>
-      </p:sp>
-      <p:sp>
-        <p:nvSpPr>
-          <p:cNvPr id="56" name="Rounded Rectangle 55"/>
-          <p:cNvSpPr/>
-          <p:nvPr/>
-        </p:nvSpPr>
-        <p:spPr>
-          <a:xfrm>
-            <a:off x="6793992" y="4462272"/>
-            <a:ext cx="393192" cy="310896"/>
-          </a:xfrm>
-          <a:prstGeom prst="roundRect">
-            <a:avLst>
-              <a:gd name="adj" fmla="val 15000"/>
-            </a:avLst>
-          </a:prstGeom>
-          <a:solidFill>
-            <a:srgbClr val="28243E"/>
           </a:solidFill>
           <a:ln w="12700">
             <a:solidFill>
@@ -8018,20 +8001,19 @@
           <a:lstStyle/>
           <a:p>
             <a:pPr algn="ctr"/>
-            <a:endParaRPr/>
-          </a:p>
-        </p:txBody>
-      </p:sp>
-      <p:sp>
-        <p:nvSpPr>
-          <p:cNvPr id="57" name="TextBox 56"/>
+          </a:p>
+        </p:txBody>
+      </p:sp>
+      <p:sp>
+        <p:nvSpPr>
+          <p:cNvPr id="98" name="TextBox 97"/>
           <p:cNvSpPr txBox="1"/>
           <p:nvPr/>
         </p:nvSpPr>
         <p:spPr>
           <a:xfrm>
-            <a:off x="6793992" y="4462272"/>
-            <a:ext cx="393192" cy="310896"/>
+            <a:off x="2560320" y="4023360"/>
+            <a:ext cx="2377440" cy="210312"/>
           </a:xfrm>
           <a:prstGeom prst="rect">
             <a:avLst/>
@@ -8039,42 +8021,117 @@
           <a:noFill/>
         </p:spPr>
         <p:txBody>
-          <a:bodyPr wrap="square" lIns="0" tIns="0" rIns="0" bIns="0" anchor="ctr">
+          <a:bodyPr wrap="square" lIns="0" rIns="0" tIns="0" bIns="0" anchor="ctr">
             <a:spAutoFit/>
           </a:bodyPr>
           <a:lstStyle/>
           <a:p>
-            <a:pPr algn="ctr"/>
-            <a:r>
-              <a:rPr sz="1200" b="0">
+            <a:pPr algn="ctr">
+              <a:spcAft>
+                <a:spcPts val="0"/>
+              </a:spcAft>
+            </a:pPr>
+            <a:r>
+              <a:rPr sz="930" b="0">
                 <a:solidFill>
-                  <a:srgbClr val="B9A8FF"/>
+                  <a:srgbClr val="EDF5FF"/>
                 </a:solidFill>
                 <a:latin typeface="Helvetica Neue"/>
               </a:rPr>
-              <a:t>1</a:t>
-            </a:r>
-          </a:p>
-        </p:txBody>
-      </p:sp>
-      <p:sp>
-        <p:nvSpPr>
-          <p:cNvPr id="58" name="Rounded Rectangle 57"/>
+              <a:t>CATEGORY_PROMPT_INJECTION</a:t>
+            </a:r>
+          </a:p>
+        </p:txBody>
+      </p:sp>
+      <p:cxnSp>
+        <p:nvCxnSpPr>
+          <p:cNvPr id="99" name="Connector 98"/>
+          <p:cNvCxnSpPr/>
+          <p:nvPr/>
+        </p:nvCxnSpPr>
+        <p:spPr>
+          <a:xfrm>
+            <a:off x="2258568" y="4393692"/>
+            <a:ext cx="256032" cy="0"/>
+          </a:xfrm>
+          <a:prstGeom prst="line">
+            <a:avLst/>
+          </a:prstGeom>
+          <a:ln w="17780">
+            <a:solidFill>
+              <a:srgbClr val="B9A8FF"/>
+            </a:solidFill>
+            <a:tailEnd type="triangle"/>
+          </a:ln>
+        </p:spPr>
+        <p:style>
+          <a:lnRef idx="2">
+            <a:schemeClr val="accent1"/>
+          </a:lnRef>
+          <a:fillRef idx="0">
+            <a:schemeClr val="accent1"/>
+          </a:fillRef>
+          <a:effectRef idx="1">
+            <a:schemeClr val="accent1"/>
+          </a:effectRef>
+          <a:fontRef idx="minor">
+            <a:schemeClr val="tx1"/>
+          </a:fontRef>
+        </p:style>
+      </p:cxnSp>
+      <p:cxnSp>
+        <p:nvCxnSpPr>
+          <p:cNvPr id="100" name="Connector 99"/>
+          <p:cNvCxnSpPr/>
+          <p:nvPr/>
+        </p:nvCxnSpPr>
+        <p:spPr>
+          <a:xfrm>
+            <a:off x="4983480" y="4393692"/>
+            <a:ext cx="228600" cy="0"/>
+          </a:xfrm>
+          <a:prstGeom prst="line">
+            <a:avLst/>
+          </a:prstGeom>
+          <a:ln w="17780">
+            <a:solidFill>
+              <a:srgbClr val="B9A8FF"/>
+            </a:solidFill>
+          </a:ln>
+        </p:spPr>
+        <p:style>
+          <a:lnRef idx="2">
+            <a:schemeClr val="accent1"/>
+          </a:lnRef>
+          <a:fillRef idx="0">
+            <a:schemeClr val="accent1"/>
+          </a:fillRef>
+          <a:effectRef idx="1">
+            <a:schemeClr val="accent1"/>
+          </a:effectRef>
+          <a:fontRef idx="minor">
+            <a:schemeClr val="tx1"/>
+          </a:fontRef>
+        </p:style>
+      </p:cxnSp>
+      <p:sp>
+        <p:nvSpPr>
+          <p:cNvPr id="101" name="Rounded Rectangle 100"/>
           <p:cNvSpPr/>
           <p:nvPr/>
         </p:nvSpPr>
         <p:spPr>
           <a:xfrm>
-            <a:off x="7260336" y="4462272"/>
-            <a:ext cx="393192" cy="310896"/>
+            <a:off x="2514600" y="4288536"/>
+            <a:ext cx="2468880" cy="210312"/>
           </a:xfrm>
           <a:prstGeom prst="roundRect">
             <a:avLst>
-              <a:gd name="adj" fmla="val 15000"/>
+              <a:gd name="adj" fmla="val 10000"/>
             </a:avLst>
           </a:prstGeom>
           <a:solidFill>
-            <a:srgbClr val="28243E"/>
+            <a:srgbClr val="122132"/>
           </a:solidFill>
           <a:ln w="12700">
             <a:solidFill>
@@ -8102,20 +8159,19 @@
           <a:lstStyle/>
           <a:p>
             <a:pPr algn="ctr"/>
-            <a:endParaRPr/>
-          </a:p>
-        </p:txBody>
-      </p:sp>
-      <p:sp>
-        <p:nvSpPr>
-          <p:cNvPr id="59" name="TextBox 58"/>
+          </a:p>
+        </p:txBody>
+      </p:sp>
+      <p:sp>
+        <p:nvSpPr>
+          <p:cNvPr id="102" name="TextBox 101"/>
           <p:cNvSpPr txBox="1"/>
           <p:nvPr/>
         </p:nvSpPr>
         <p:spPr>
           <a:xfrm>
-            <a:off x="7260336" y="4462272"/>
-            <a:ext cx="393192" cy="310896"/>
+            <a:off x="2560320" y="4288536"/>
+            <a:ext cx="2377440" cy="210312"/>
           </a:xfrm>
           <a:prstGeom prst="rect">
             <a:avLst/>
@@ -8123,42 +8179,117 @@
           <a:noFill/>
         </p:spPr>
         <p:txBody>
-          <a:bodyPr wrap="square" lIns="0" tIns="0" rIns="0" bIns="0" anchor="ctr">
+          <a:bodyPr wrap="square" lIns="0" rIns="0" tIns="0" bIns="0" anchor="ctr">
             <a:spAutoFit/>
           </a:bodyPr>
           <a:lstStyle/>
           <a:p>
-            <a:pPr algn="ctr"/>
-            <a:r>
-              <a:rPr sz="1200" b="0">
+            <a:pPr algn="ctr">
+              <a:spcAft>
+                <a:spcPts val="0"/>
+              </a:spcAft>
+            </a:pPr>
+            <a:r>
+              <a:rPr sz="930" b="0">
                 <a:solidFill>
-                  <a:srgbClr val="B9A8FF"/>
+                  <a:srgbClr val="EDF5FF"/>
                 </a:solidFill>
                 <a:latin typeface="Helvetica Neue"/>
               </a:rPr>
-              <a:t>2</a:t>
-            </a:r>
-          </a:p>
-        </p:txBody>
-      </p:sp>
-      <p:sp>
-        <p:nvSpPr>
-          <p:cNvPr id="60" name="Rounded Rectangle 59"/>
+              <a:t>CATEGORY_PII_EXTRACTION</a:t>
+            </a:r>
+          </a:p>
+        </p:txBody>
+      </p:sp>
+      <p:cxnSp>
+        <p:nvCxnSpPr>
+          <p:cNvPr id="103" name="Connector 102"/>
+          <p:cNvCxnSpPr/>
+          <p:nvPr/>
+        </p:nvCxnSpPr>
+        <p:spPr>
+          <a:xfrm>
+            <a:off x="2258568" y="4658868"/>
+            <a:ext cx="256032" cy="0"/>
+          </a:xfrm>
+          <a:prstGeom prst="line">
+            <a:avLst/>
+          </a:prstGeom>
+          <a:ln w="17780">
+            <a:solidFill>
+              <a:srgbClr val="B9A8FF"/>
+            </a:solidFill>
+            <a:tailEnd type="triangle"/>
+          </a:ln>
+        </p:spPr>
+        <p:style>
+          <a:lnRef idx="2">
+            <a:schemeClr val="accent1"/>
+          </a:lnRef>
+          <a:fillRef idx="0">
+            <a:schemeClr val="accent1"/>
+          </a:fillRef>
+          <a:effectRef idx="1">
+            <a:schemeClr val="accent1"/>
+          </a:effectRef>
+          <a:fontRef idx="minor">
+            <a:schemeClr val="tx1"/>
+          </a:fontRef>
+        </p:style>
+      </p:cxnSp>
+      <p:cxnSp>
+        <p:nvCxnSpPr>
+          <p:cNvPr id="104" name="Connector 103"/>
+          <p:cNvCxnSpPr/>
+          <p:nvPr/>
+        </p:nvCxnSpPr>
+        <p:spPr>
+          <a:xfrm>
+            <a:off x="4983480" y="4658868"/>
+            <a:ext cx="228600" cy="0"/>
+          </a:xfrm>
+          <a:prstGeom prst="line">
+            <a:avLst/>
+          </a:prstGeom>
+          <a:ln w="17780">
+            <a:solidFill>
+              <a:srgbClr val="B9A8FF"/>
+            </a:solidFill>
+          </a:ln>
+        </p:spPr>
+        <p:style>
+          <a:lnRef idx="2">
+            <a:schemeClr val="accent1"/>
+          </a:lnRef>
+          <a:fillRef idx="0">
+            <a:schemeClr val="accent1"/>
+          </a:fillRef>
+          <a:effectRef idx="1">
+            <a:schemeClr val="accent1"/>
+          </a:effectRef>
+          <a:fontRef idx="minor">
+            <a:schemeClr val="tx1"/>
+          </a:fontRef>
+        </p:style>
+      </p:cxnSp>
+      <p:sp>
+        <p:nvSpPr>
+          <p:cNvPr id="105" name="Rounded Rectangle 104"/>
           <p:cNvSpPr/>
           <p:nvPr/>
         </p:nvSpPr>
         <p:spPr>
           <a:xfrm>
-            <a:off x="7726679" y="4462272"/>
-            <a:ext cx="393192" cy="310896"/>
+            <a:off x="2514600" y="4553712"/>
+            <a:ext cx="2468880" cy="210312"/>
           </a:xfrm>
           <a:prstGeom prst="roundRect">
             <a:avLst>
-              <a:gd name="adj" fmla="val 15000"/>
+              <a:gd name="adj" fmla="val 10000"/>
             </a:avLst>
           </a:prstGeom>
           <a:solidFill>
-            <a:srgbClr val="28243E"/>
+            <a:srgbClr val="122132"/>
           </a:solidFill>
           <a:ln w="12700">
             <a:solidFill>
@@ -8186,20 +8317,19 @@
           <a:lstStyle/>
           <a:p>
             <a:pPr algn="ctr"/>
-            <a:endParaRPr/>
-          </a:p>
-        </p:txBody>
-      </p:sp>
-      <p:sp>
-        <p:nvSpPr>
-          <p:cNvPr id="61" name="TextBox 60"/>
+          </a:p>
+        </p:txBody>
+      </p:sp>
+      <p:sp>
+        <p:nvSpPr>
+          <p:cNvPr id="106" name="TextBox 105"/>
           <p:cNvSpPr txBox="1"/>
           <p:nvPr/>
         </p:nvSpPr>
         <p:spPr>
           <a:xfrm>
-            <a:off x="7726679" y="4462272"/>
-            <a:ext cx="393192" cy="310896"/>
+            <a:off x="2560320" y="4553712"/>
+            <a:ext cx="2377440" cy="210312"/>
           </a:xfrm>
           <a:prstGeom prst="rect">
             <a:avLst/>
@@ -8207,42 +8337,117 @@
           <a:noFill/>
         </p:spPr>
         <p:txBody>
-          <a:bodyPr wrap="square" lIns="0" tIns="0" rIns="0" bIns="0" anchor="ctr">
+          <a:bodyPr wrap="square" lIns="0" rIns="0" tIns="0" bIns="0" anchor="ctr">
             <a:spAutoFit/>
           </a:bodyPr>
           <a:lstStyle/>
           <a:p>
-            <a:pPr algn="ctr"/>
-            <a:r>
-              <a:rPr sz="1200" b="0">
+            <a:pPr algn="ctr">
+              <a:spcAft>
+                <a:spcPts val="0"/>
+              </a:spcAft>
+            </a:pPr>
+            <a:r>
+              <a:rPr sz="930" b="0">
                 <a:solidFill>
-                  <a:srgbClr val="B9A8FF"/>
+                  <a:srgbClr val="EDF5FF"/>
                 </a:solidFill>
                 <a:latin typeface="Helvetica Neue"/>
               </a:rPr>
-              <a:t>3</a:t>
-            </a:r>
-          </a:p>
-        </p:txBody>
-      </p:sp>
-      <p:sp>
-        <p:nvSpPr>
-          <p:cNvPr id="62" name="Rounded Rectangle 61"/>
+              <a:t>CATEGORY_SCOPE_VIOLATION</a:t>
+            </a:r>
+          </a:p>
+        </p:txBody>
+      </p:sp>
+      <p:cxnSp>
+        <p:nvCxnSpPr>
+          <p:cNvPr id="107" name="Connector 106"/>
+          <p:cNvCxnSpPr/>
+          <p:nvPr/>
+        </p:nvCxnSpPr>
+        <p:spPr>
+          <a:xfrm>
+            <a:off x="2258568" y="4924044"/>
+            <a:ext cx="256032" cy="0"/>
+          </a:xfrm>
+          <a:prstGeom prst="line">
+            <a:avLst/>
+          </a:prstGeom>
+          <a:ln w="17780">
+            <a:solidFill>
+              <a:srgbClr val="B9A8FF"/>
+            </a:solidFill>
+            <a:tailEnd type="triangle"/>
+          </a:ln>
+        </p:spPr>
+        <p:style>
+          <a:lnRef idx="2">
+            <a:schemeClr val="accent1"/>
+          </a:lnRef>
+          <a:fillRef idx="0">
+            <a:schemeClr val="accent1"/>
+          </a:fillRef>
+          <a:effectRef idx="1">
+            <a:schemeClr val="accent1"/>
+          </a:effectRef>
+          <a:fontRef idx="minor">
+            <a:schemeClr val="tx1"/>
+          </a:fontRef>
+        </p:style>
+      </p:cxnSp>
+      <p:cxnSp>
+        <p:nvCxnSpPr>
+          <p:cNvPr id="108" name="Connector 107"/>
+          <p:cNvCxnSpPr/>
+          <p:nvPr/>
+        </p:nvCxnSpPr>
+        <p:spPr>
+          <a:xfrm>
+            <a:off x="4983480" y="4924044"/>
+            <a:ext cx="228600" cy="0"/>
+          </a:xfrm>
+          <a:prstGeom prst="line">
+            <a:avLst/>
+          </a:prstGeom>
+          <a:ln w="17780">
+            <a:solidFill>
+              <a:srgbClr val="B9A8FF"/>
+            </a:solidFill>
+          </a:ln>
+        </p:spPr>
+        <p:style>
+          <a:lnRef idx="2">
+            <a:schemeClr val="accent1"/>
+          </a:lnRef>
+          <a:fillRef idx="0">
+            <a:schemeClr val="accent1"/>
+          </a:fillRef>
+          <a:effectRef idx="1">
+            <a:schemeClr val="accent1"/>
+          </a:effectRef>
+          <a:fontRef idx="minor">
+            <a:schemeClr val="tx1"/>
+          </a:fontRef>
+        </p:style>
+      </p:cxnSp>
+      <p:sp>
+        <p:nvSpPr>
+          <p:cNvPr id="109" name="Rounded Rectangle 108"/>
           <p:cNvSpPr/>
           <p:nvPr/>
         </p:nvSpPr>
         <p:spPr>
           <a:xfrm>
-            <a:off x="8193023" y="4462272"/>
-            <a:ext cx="393192" cy="310896"/>
+            <a:off x="2514600" y="4818888"/>
+            <a:ext cx="2468880" cy="210312"/>
           </a:xfrm>
           <a:prstGeom prst="roundRect">
             <a:avLst>
-              <a:gd name="adj" fmla="val 15000"/>
+              <a:gd name="adj" fmla="val 10000"/>
             </a:avLst>
           </a:prstGeom>
           <a:solidFill>
-            <a:srgbClr val="28243E"/>
+            <a:srgbClr val="122132"/>
           </a:solidFill>
           <a:ln w="12700">
             <a:solidFill>
@@ -8270,20 +8475,19 @@
           <a:lstStyle/>
           <a:p>
             <a:pPr algn="ctr"/>
-            <a:endParaRPr/>
-          </a:p>
-        </p:txBody>
-      </p:sp>
-      <p:sp>
-        <p:nvSpPr>
-          <p:cNvPr id="63" name="TextBox 62"/>
+          </a:p>
+        </p:txBody>
+      </p:sp>
+      <p:sp>
+        <p:nvSpPr>
+          <p:cNvPr id="110" name="TextBox 109"/>
           <p:cNvSpPr txBox="1"/>
           <p:nvPr/>
         </p:nvSpPr>
         <p:spPr>
           <a:xfrm>
-            <a:off x="8193023" y="4462272"/>
-            <a:ext cx="393192" cy="310896"/>
+            <a:off x="2560320" y="4818888"/>
+            <a:ext cx="2377440" cy="210312"/>
           </a:xfrm>
           <a:prstGeom prst="rect">
             <a:avLst/>
@@ -8291,34 +8495,903 @@
           <a:noFill/>
         </p:spPr>
         <p:txBody>
-          <a:bodyPr wrap="square" lIns="0" tIns="0" rIns="0" bIns="0" anchor="ctr">
+          <a:bodyPr wrap="square" lIns="0" rIns="0" tIns="0" bIns="0" anchor="ctr">
             <a:spAutoFit/>
           </a:bodyPr>
           <a:lstStyle/>
           <a:p>
+            <a:pPr algn="ctr">
+              <a:spcAft>
+                <a:spcPts val="0"/>
+              </a:spcAft>
+            </a:pPr>
+            <a:r>
+              <a:rPr sz="930" b="0">
+                <a:solidFill>
+                  <a:srgbClr val="EDF5FF"/>
+                </a:solidFill>
+                <a:latin typeface="Helvetica Neue"/>
+              </a:rPr>
+              <a:t>CATEGORY_SOCIAL_ENGINEERING</a:t>
+            </a:r>
+          </a:p>
+        </p:txBody>
+      </p:sp>
+      <p:cxnSp>
+        <p:nvCxnSpPr>
+          <p:cNvPr id="111" name="Connector 110"/>
+          <p:cNvCxnSpPr/>
+          <p:nvPr/>
+        </p:nvCxnSpPr>
+        <p:spPr>
+          <a:xfrm>
+            <a:off x="2258568" y="5189220"/>
+            <a:ext cx="256032" cy="0"/>
+          </a:xfrm>
+          <a:prstGeom prst="line">
+            <a:avLst/>
+          </a:prstGeom>
+          <a:ln w="17780">
+            <a:solidFill>
+              <a:srgbClr val="B9A8FF"/>
+            </a:solidFill>
+            <a:tailEnd type="triangle"/>
+          </a:ln>
+        </p:spPr>
+        <p:style>
+          <a:lnRef idx="2">
+            <a:schemeClr val="accent1"/>
+          </a:lnRef>
+          <a:fillRef idx="0">
+            <a:schemeClr val="accent1"/>
+          </a:fillRef>
+          <a:effectRef idx="1">
+            <a:schemeClr val="accent1"/>
+          </a:effectRef>
+          <a:fontRef idx="minor">
+            <a:schemeClr val="tx1"/>
+          </a:fontRef>
+        </p:style>
+      </p:cxnSp>
+      <p:cxnSp>
+        <p:nvCxnSpPr>
+          <p:cNvPr id="112" name="Connector 111"/>
+          <p:cNvCxnSpPr/>
+          <p:nvPr/>
+        </p:nvCxnSpPr>
+        <p:spPr>
+          <a:xfrm>
+            <a:off x="4983480" y="5189220"/>
+            <a:ext cx="228600" cy="0"/>
+          </a:xfrm>
+          <a:prstGeom prst="line">
+            <a:avLst/>
+          </a:prstGeom>
+          <a:ln w="17780">
+            <a:solidFill>
+              <a:srgbClr val="B9A8FF"/>
+            </a:solidFill>
+          </a:ln>
+        </p:spPr>
+        <p:style>
+          <a:lnRef idx="2">
+            <a:schemeClr val="accent1"/>
+          </a:lnRef>
+          <a:fillRef idx="0">
+            <a:schemeClr val="accent1"/>
+          </a:fillRef>
+          <a:effectRef idx="1">
+            <a:schemeClr val="accent1"/>
+          </a:effectRef>
+          <a:fontRef idx="minor">
+            <a:schemeClr val="tx1"/>
+          </a:fontRef>
+        </p:style>
+      </p:cxnSp>
+      <p:sp>
+        <p:nvSpPr>
+          <p:cNvPr id="113" name="Rounded Rectangle 112"/>
+          <p:cNvSpPr/>
+          <p:nvPr/>
+        </p:nvSpPr>
+        <p:spPr>
+          <a:xfrm>
+            <a:off x="2514600" y="5084064"/>
+            <a:ext cx="2468880" cy="210312"/>
+          </a:xfrm>
+          <a:prstGeom prst="roundRect">
+            <a:avLst>
+              <a:gd name="adj" fmla="val 10000"/>
+            </a:avLst>
+          </a:prstGeom>
+          <a:solidFill>
+            <a:srgbClr val="122132"/>
+          </a:solidFill>
+          <a:ln w="12700">
+            <a:solidFill>
+              <a:srgbClr val="B9A8FF"/>
+            </a:solidFill>
+          </a:ln>
+          <a:effectLst/>
+        </p:spPr>
+        <p:style>
+          <a:lnRef idx="1">
+            <a:schemeClr val="accent1"/>
+          </a:lnRef>
+          <a:fillRef idx="3">
+            <a:schemeClr val="accent1"/>
+          </a:fillRef>
+          <a:effectRef idx="2">
+            <a:schemeClr val="accent1"/>
+          </a:effectRef>
+          <a:fontRef idx="minor">
+            <a:schemeClr val="lt1"/>
+          </a:fontRef>
+        </p:style>
+        <p:txBody>
+          <a:bodyPr rtlCol="0" anchor="ctr"/>
+          <a:lstStyle/>
+          <a:p>
             <a:pPr algn="ctr"/>
-            <a:r>
-              <a:rPr sz="1200" b="0">
+          </a:p>
+        </p:txBody>
+      </p:sp>
+      <p:sp>
+        <p:nvSpPr>
+          <p:cNvPr id="114" name="TextBox 113"/>
+          <p:cNvSpPr txBox="1"/>
+          <p:nvPr/>
+        </p:nvSpPr>
+        <p:spPr>
+          <a:xfrm>
+            <a:off x="2560320" y="5084064"/>
+            <a:ext cx="2377440" cy="210312"/>
+          </a:xfrm>
+          <a:prstGeom prst="rect">
+            <a:avLst/>
+          </a:prstGeom>
+          <a:noFill/>
+        </p:spPr>
+        <p:txBody>
+          <a:bodyPr wrap="square" lIns="0" rIns="0" tIns="0" bIns="0" anchor="ctr">
+            <a:spAutoFit/>
+          </a:bodyPr>
+          <a:lstStyle/>
+          <a:p>
+            <a:pPr algn="ctr">
+              <a:spcAft>
+                <a:spcPts val="0"/>
+              </a:spcAft>
+            </a:pPr>
+            <a:r>
+              <a:rPr sz="930" b="0">
+                <a:solidFill>
+                  <a:srgbClr val="EDF5FF"/>
+                </a:solidFill>
+                <a:latin typeface="Helvetica Neue"/>
+              </a:rPr>
+              <a:t>CATEGORY_MULTI_TURN</a:t>
+            </a:r>
+          </a:p>
+        </p:txBody>
+      </p:sp>
+      <p:cxnSp>
+        <p:nvCxnSpPr>
+          <p:cNvPr id="115" name="Connector 114"/>
+          <p:cNvCxnSpPr/>
+          <p:nvPr/>
+        </p:nvCxnSpPr>
+        <p:spPr>
+          <a:xfrm>
+            <a:off x="2258568" y="5454396"/>
+            <a:ext cx="256032" cy="0"/>
+          </a:xfrm>
+          <a:prstGeom prst="line">
+            <a:avLst/>
+          </a:prstGeom>
+          <a:ln w="17780">
+            <a:solidFill>
+              <a:srgbClr val="B9A8FF"/>
+            </a:solidFill>
+            <a:tailEnd type="triangle"/>
+          </a:ln>
+        </p:spPr>
+        <p:style>
+          <a:lnRef idx="2">
+            <a:schemeClr val="accent1"/>
+          </a:lnRef>
+          <a:fillRef idx="0">
+            <a:schemeClr val="accent1"/>
+          </a:fillRef>
+          <a:effectRef idx="1">
+            <a:schemeClr val="accent1"/>
+          </a:effectRef>
+          <a:fontRef idx="minor">
+            <a:schemeClr val="tx1"/>
+          </a:fontRef>
+        </p:style>
+      </p:cxnSp>
+      <p:cxnSp>
+        <p:nvCxnSpPr>
+          <p:cNvPr id="116" name="Connector 115"/>
+          <p:cNvCxnSpPr/>
+          <p:nvPr/>
+        </p:nvCxnSpPr>
+        <p:spPr>
+          <a:xfrm>
+            <a:off x="4983480" y="5454396"/>
+            <a:ext cx="228600" cy="0"/>
+          </a:xfrm>
+          <a:prstGeom prst="line">
+            <a:avLst/>
+          </a:prstGeom>
+          <a:ln w="17780">
+            <a:solidFill>
+              <a:srgbClr val="B9A8FF"/>
+            </a:solidFill>
+          </a:ln>
+        </p:spPr>
+        <p:style>
+          <a:lnRef idx="2">
+            <a:schemeClr val="accent1"/>
+          </a:lnRef>
+          <a:fillRef idx="0">
+            <a:schemeClr val="accent1"/>
+          </a:fillRef>
+          <a:effectRef idx="1">
+            <a:schemeClr val="accent1"/>
+          </a:effectRef>
+          <a:fontRef idx="minor">
+            <a:schemeClr val="tx1"/>
+          </a:fontRef>
+        </p:style>
+      </p:cxnSp>
+      <p:sp>
+        <p:nvSpPr>
+          <p:cNvPr id="117" name="Rounded Rectangle 116"/>
+          <p:cNvSpPr/>
+          <p:nvPr/>
+        </p:nvSpPr>
+        <p:spPr>
+          <a:xfrm>
+            <a:off x="2514600" y="5349240"/>
+            <a:ext cx="2468880" cy="210312"/>
+          </a:xfrm>
+          <a:prstGeom prst="roundRect">
+            <a:avLst>
+              <a:gd name="adj" fmla="val 10000"/>
+            </a:avLst>
+          </a:prstGeom>
+          <a:solidFill>
+            <a:srgbClr val="122132"/>
+          </a:solidFill>
+          <a:ln w="12700">
+            <a:solidFill>
+              <a:srgbClr val="B9A8FF"/>
+            </a:solidFill>
+          </a:ln>
+          <a:effectLst/>
+        </p:spPr>
+        <p:style>
+          <a:lnRef idx="1">
+            <a:schemeClr val="accent1"/>
+          </a:lnRef>
+          <a:fillRef idx="3">
+            <a:schemeClr val="accent1"/>
+          </a:fillRef>
+          <a:effectRef idx="2">
+            <a:schemeClr val="accent1"/>
+          </a:effectRef>
+          <a:fontRef idx="minor">
+            <a:schemeClr val="lt1"/>
+          </a:fontRef>
+        </p:style>
+        <p:txBody>
+          <a:bodyPr rtlCol="0" anchor="ctr"/>
+          <a:lstStyle/>
+          <a:p>
+            <a:pPr algn="ctr"/>
+          </a:p>
+        </p:txBody>
+      </p:sp>
+      <p:sp>
+        <p:nvSpPr>
+          <p:cNvPr id="118" name="TextBox 117"/>
+          <p:cNvSpPr txBox="1"/>
+          <p:nvPr/>
+        </p:nvSpPr>
+        <p:spPr>
+          <a:xfrm>
+            <a:off x="2560320" y="5349240"/>
+            <a:ext cx="2377440" cy="210312"/>
+          </a:xfrm>
+          <a:prstGeom prst="rect">
+            <a:avLst/>
+          </a:prstGeom>
+          <a:noFill/>
+        </p:spPr>
+        <p:txBody>
+          <a:bodyPr wrap="square" lIns="0" rIns="0" tIns="0" bIns="0" anchor="ctr">
+            <a:spAutoFit/>
+          </a:bodyPr>
+          <a:lstStyle/>
+          <a:p>
+            <a:pPr algn="ctr">
+              <a:spcAft>
+                <a:spcPts val="0"/>
+              </a:spcAft>
+            </a:pPr>
+            <a:r>
+              <a:rPr sz="930" b="0">
+                <a:solidFill>
+                  <a:srgbClr val="EDF5FF"/>
+                </a:solidFill>
+                <a:latin typeface="Helvetica Neue"/>
+              </a:rPr>
+              <a:t>CATEGORY_DATA_EXFILTRATION</a:t>
+            </a:r>
+          </a:p>
+        </p:txBody>
+      </p:sp>
+      <p:cxnSp>
+        <p:nvCxnSpPr>
+          <p:cNvPr id="119" name="Connector 118"/>
+          <p:cNvCxnSpPr/>
+          <p:nvPr/>
+        </p:nvCxnSpPr>
+        <p:spPr>
+          <a:xfrm>
+            <a:off x="2258568" y="5719572"/>
+            <a:ext cx="256032" cy="0"/>
+          </a:xfrm>
+          <a:prstGeom prst="line">
+            <a:avLst/>
+          </a:prstGeom>
+          <a:ln w="17780">
+            <a:solidFill>
+              <a:srgbClr val="B9A8FF"/>
+            </a:solidFill>
+            <a:tailEnd type="triangle"/>
+          </a:ln>
+        </p:spPr>
+        <p:style>
+          <a:lnRef idx="2">
+            <a:schemeClr val="accent1"/>
+          </a:lnRef>
+          <a:fillRef idx="0">
+            <a:schemeClr val="accent1"/>
+          </a:fillRef>
+          <a:effectRef idx="1">
+            <a:schemeClr val="accent1"/>
+          </a:effectRef>
+          <a:fontRef idx="minor">
+            <a:schemeClr val="tx1"/>
+          </a:fontRef>
+        </p:style>
+      </p:cxnSp>
+      <p:cxnSp>
+        <p:nvCxnSpPr>
+          <p:cNvPr id="120" name="Connector 119"/>
+          <p:cNvCxnSpPr/>
+          <p:nvPr/>
+        </p:nvCxnSpPr>
+        <p:spPr>
+          <a:xfrm>
+            <a:off x="4983480" y="5719572"/>
+            <a:ext cx="228600" cy="0"/>
+          </a:xfrm>
+          <a:prstGeom prst="line">
+            <a:avLst/>
+          </a:prstGeom>
+          <a:ln w="17780">
+            <a:solidFill>
+              <a:srgbClr val="B9A8FF"/>
+            </a:solidFill>
+          </a:ln>
+        </p:spPr>
+        <p:style>
+          <a:lnRef idx="2">
+            <a:schemeClr val="accent1"/>
+          </a:lnRef>
+          <a:fillRef idx="0">
+            <a:schemeClr val="accent1"/>
+          </a:fillRef>
+          <a:effectRef idx="1">
+            <a:schemeClr val="accent1"/>
+          </a:effectRef>
+          <a:fontRef idx="minor">
+            <a:schemeClr val="tx1"/>
+          </a:fontRef>
+        </p:style>
+      </p:cxnSp>
+      <p:sp>
+        <p:nvSpPr>
+          <p:cNvPr id="121" name="Rounded Rectangle 120"/>
+          <p:cNvSpPr/>
+          <p:nvPr/>
+        </p:nvSpPr>
+        <p:spPr>
+          <a:xfrm>
+            <a:off x="2514600" y="5614416"/>
+            <a:ext cx="2468880" cy="210312"/>
+          </a:xfrm>
+          <a:prstGeom prst="roundRect">
+            <a:avLst>
+              <a:gd name="adj" fmla="val 10000"/>
+            </a:avLst>
+          </a:prstGeom>
+          <a:solidFill>
+            <a:srgbClr val="122132"/>
+          </a:solidFill>
+          <a:ln w="12700">
+            <a:solidFill>
+              <a:srgbClr val="B9A8FF"/>
+            </a:solidFill>
+          </a:ln>
+          <a:effectLst/>
+        </p:spPr>
+        <p:style>
+          <a:lnRef idx="1">
+            <a:schemeClr val="accent1"/>
+          </a:lnRef>
+          <a:fillRef idx="3">
+            <a:schemeClr val="accent1"/>
+          </a:fillRef>
+          <a:effectRef idx="2">
+            <a:schemeClr val="accent1"/>
+          </a:effectRef>
+          <a:fontRef idx="minor">
+            <a:schemeClr val="lt1"/>
+          </a:fontRef>
+        </p:style>
+        <p:txBody>
+          <a:bodyPr rtlCol="0" anchor="ctr"/>
+          <a:lstStyle/>
+          <a:p>
+            <a:pPr algn="ctr"/>
+          </a:p>
+        </p:txBody>
+      </p:sp>
+      <p:sp>
+        <p:nvSpPr>
+          <p:cNvPr id="122" name="TextBox 121"/>
+          <p:cNvSpPr txBox="1"/>
+          <p:nvPr/>
+        </p:nvSpPr>
+        <p:spPr>
+          <a:xfrm>
+            <a:off x="2560320" y="5614416"/>
+            <a:ext cx="2377440" cy="210312"/>
+          </a:xfrm>
+          <a:prstGeom prst="rect">
+            <a:avLst/>
+          </a:prstGeom>
+          <a:noFill/>
+        </p:spPr>
+        <p:txBody>
+          <a:bodyPr wrap="square" lIns="0" rIns="0" tIns="0" bIns="0" anchor="ctr">
+            <a:spAutoFit/>
+          </a:bodyPr>
+          <a:lstStyle/>
+          <a:p>
+            <a:pPr algn="ctr">
+              <a:spcAft>
+                <a:spcPts val="0"/>
+              </a:spcAft>
+            </a:pPr>
+            <a:r>
+              <a:rPr sz="930" b="0">
+                <a:solidFill>
+                  <a:srgbClr val="EDF5FF"/>
+                </a:solidFill>
+                <a:latin typeface="Helvetica Neue"/>
+              </a:rPr>
+              <a:t>CATEGORY_ROLE_ESCALATION</a:t>
+            </a:r>
+          </a:p>
+        </p:txBody>
+      </p:sp>
+      <p:cxnSp>
+        <p:nvCxnSpPr>
+          <p:cNvPr id="123" name="Connector 122"/>
+          <p:cNvCxnSpPr/>
+          <p:nvPr/>
+        </p:nvCxnSpPr>
+        <p:spPr>
+          <a:xfrm>
+            <a:off x="2258568" y="5984748"/>
+            <a:ext cx="256032" cy="0"/>
+          </a:xfrm>
+          <a:prstGeom prst="line">
+            <a:avLst/>
+          </a:prstGeom>
+          <a:ln w="17780">
+            <a:solidFill>
+              <a:srgbClr val="B9A8FF"/>
+            </a:solidFill>
+            <a:tailEnd type="triangle"/>
+          </a:ln>
+        </p:spPr>
+        <p:style>
+          <a:lnRef idx="2">
+            <a:schemeClr val="accent1"/>
+          </a:lnRef>
+          <a:fillRef idx="0">
+            <a:schemeClr val="accent1"/>
+          </a:fillRef>
+          <a:effectRef idx="1">
+            <a:schemeClr val="accent1"/>
+          </a:effectRef>
+          <a:fontRef idx="minor">
+            <a:schemeClr val="tx1"/>
+          </a:fontRef>
+        </p:style>
+      </p:cxnSp>
+      <p:cxnSp>
+        <p:nvCxnSpPr>
+          <p:cNvPr id="124" name="Connector 123"/>
+          <p:cNvCxnSpPr/>
+          <p:nvPr/>
+        </p:nvCxnSpPr>
+        <p:spPr>
+          <a:xfrm>
+            <a:off x="4983480" y="5984748"/>
+            <a:ext cx="228600" cy="0"/>
+          </a:xfrm>
+          <a:prstGeom prst="line">
+            <a:avLst/>
+          </a:prstGeom>
+          <a:ln w="17780">
+            <a:solidFill>
+              <a:srgbClr val="B9A8FF"/>
+            </a:solidFill>
+          </a:ln>
+        </p:spPr>
+        <p:style>
+          <a:lnRef idx="2">
+            <a:schemeClr val="accent1"/>
+          </a:lnRef>
+          <a:fillRef idx="0">
+            <a:schemeClr val="accent1"/>
+          </a:fillRef>
+          <a:effectRef idx="1">
+            <a:schemeClr val="accent1"/>
+          </a:effectRef>
+          <a:fontRef idx="minor">
+            <a:schemeClr val="tx1"/>
+          </a:fontRef>
+        </p:style>
+      </p:cxnSp>
+      <p:sp>
+        <p:nvSpPr>
+          <p:cNvPr id="125" name="Rounded Rectangle 124"/>
+          <p:cNvSpPr/>
+          <p:nvPr/>
+        </p:nvSpPr>
+        <p:spPr>
+          <a:xfrm>
+            <a:off x="2514600" y="5879592"/>
+            <a:ext cx="2468880" cy="210312"/>
+          </a:xfrm>
+          <a:prstGeom prst="roundRect">
+            <a:avLst>
+              <a:gd name="adj" fmla="val 10000"/>
+            </a:avLst>
+          </a:prstGeom>
+          <a:solidFill>
+            <a:srgbClr val="122132"/>
+          </a:solidFill>
+          <a:ln w="12700">
+            <a:solidFill>
+              <a:srgbClr val="B9A8FF"/>
+            </a:solidFill>
+          </a:ln>
+          <a:effectLst/>
+        </p:spPr>
+        <p:style>
+          <a:lnRef idx="1">
+            <a:schemeClr val="accent1"/>
+          </a:lnRef>
+          <a:fillRef idx="3">
+            <a:schemeClr val="accent1"/>
+          </a:fillRef>
+          <a:effectRef idx="2">
+            <a:schemeClr val="accent1"/>
+          </a:effectRef>
+          <a:fontRef idx="minor">
+            <a:schemeClr val="lt1"/>
+          </a:fontRef>
+        </p:style>
+        <p:txBody>
+          <a:bodyPr rtlCol="0" anchor="ctr"/>
+          <a:lstStyle/>
+          <a:p>
+            <a:pPr algn="ctr"/>
+          </a:p>
+        </p:txBody>
+      </p:sp>
+      <p:sp>
+        <p:nvSpPr>
+          <p:cNvPr id="126" name="TextBox 125"/>
+          <p:cNvSpPr txBox="1"/>
+          <p:nvPr/>
+        </p:nvSpPr>
+        <p:spPr>
+          <a:xfrm>
+            <a:off x="2560320" y="5879592"/>
+            <a:ext cx="2377440" cy="210312"/>
+          </a:xfrm>
+          <a:prstGeom prst="rect">
+            <a:avLst/>
+          </a:prstGeom>
+          <a:noFill/>
+        </p:spPr>
+        <p:txBody>
+          <a:bodyPr wrap="square" lIns="0" rIns="0" tIns="0" bIns="0" anchor="ctr">
+            <a:spAutoFit/>
+          </a:bodyPr>
+          <a:lstStyle/>
+          <a:p>
+            <a:pPr algn="ctr">
+              <a:spcAft>
+                <a:spcPts val="0"/>
+              </a:spcAft>
+            </a:pPr>
+            <a:r>
+              <a:rPr sz="930" b="0">
+                <a:solidFill>
+                  <a:srgbClr val="EDF5FF"/>
+                </a:solidFill>
+                <a:latin typeface="Helvetica Neue"/>
+              </a:rPr>
+              <a:t>CATEGORY_INDIRECT_INJECTION</a:t>
+            </a:r>
+          </a:p>
+        </p:txBody>
+      </p:sp>
+      <p:cxnSp>
+        <p:nvCxnSpPr>
+          <p:cNvPr id="127" name="Connector 126"/>
+          <p:cNvCxnSpPr/>
+          <p:nvPr/>
+        </p:nvCxnSpPr>
+        <p:spPr>
+          <a:xfrm>
+            <a:off x="5212080" y="4901184"/>
+            <a:ext cx="228600" cy="0"/>
+          </a:xfrm>
+          <a:prstGeom prst="line">
+            <a:avLst/>
+          </a:prstGeom>
+          <a:ln w="17780">
+            <a:solidFill>
+              <a:srgbClr val="B9A8FF"/>
+            </a:solidFill>
+            <a:tailEnd type="triangle"/>
+          </a:ln>
+        </p:spPr>
+        <p:style>
+          <a:lnRef idx="2">
+            <a:schemeClr val="accent1"/>
+          </a:lnRef>
+          <a:fillRef idx="0">
+            <a:schemeClr val="accent1"/>
+          </a:fillRef>
+          <a:effectRef idx="1">
+            <a:schemeClr val="accent1"/>
+          </a:effectRef>
+          <a:fontRef idx="minor">
+            <a:schemeClr val="tx1"/>
+          </a:fontRef>
+        </p:style>
+      </p:cxnSp>
+      <p:sp>
+        <p:nvSpPr>
+          <p:cNvPr id="128" name="Rounded Rectangle 127"/>
+          <p:cNvSpPr/>
+          <p:nvPr/>
+        </p:nvSpPr>
+        <p:spPr>
+          <a:xfrm>
+            <a:off x="5440680" y="4389120"/>
+            <a:ext cx="1600200" cy="1216152"/>
+          </a:xfrm>
+          <a:prstGeom prst="roundRect">
+            <a:avLst>
+              <a:gd name="adj" fmla="val 10000"/>
+            </a:avLst>
+          </a:prstGeom>
+          <a:solidFill>
+            <a:srgbClr val="122132"/>
+          </a:solidFill>
+          <a:ln w="12700">
+            <a:solidFill>
+              <a:srgbClr val="60C7F0"/>
+            </a:solidFill>
+          </a:ln>
+          <a:effectLst/>
+        </p:spPr>
+        <p:style>
+          <a:lnRef idx="1">
+            <a:schemeClr val="accent1"/>
+          </a:lnRef>
+          <a:fillRef idx="3">
+            <a:schemeClr val="accent1"/>
+          </a:fillRef>
+          <a:effectRef idx="2">
+            <a:schemeClr val="accent1"/>
+          </a:effectRef>
+          <a:fontRef idx="minor">
+            <a:schemeClr val="lt1"/>
+          </a:fontRef>
+        </p:style>
+        <p:txBody>
+          <a:bodyPr rtlCol="0" anchor="ctr"/>
+          <a:lstStyle/>
+          <a:p>
+            <a:pPr algn="ctr"/>
+          </a:p>
+        </p:txBody>
+      </p:sp>
+      <p:sp>
+        <p:nvSpPr>
+          <p:cNvPr id="129" name="TextBox 128"/>
+          <p:cNvSpPr txBox="1"/>
+          <p:nvPr/>
+        </p:nvSpPr>
+        <p:spPr>
+          <a:xfrm>
+            <a:off x="5486400" y="4489704"/>
+            <a:ext cx="1508760" cy="320040"/>
+          </a:xfrm>
+          <a:prstGeom prst="rect">
+            <a:avLst/>
+          </a:prstGeom>
+          <a:noFill/>
+        </p:spPr>
+        <p:txBody>
+          <a:bodyPr wrap="square" lIns="0" rIns="0" tIns="0" bIns="0" anchor="ctr">
+            <a:spAutoFit/>
+          </a:bodyPr>
+          <a:lstStyle/>
+          <a:p>
+            <a:pPr algn="ctr">
+              <a:spcAft>
+                <a:spcPts val="0"/>
+              </a:spcAft>
+            </a:pPr>
+            <a:r>
+              <a:rPr sz="1500" b="1">
+                <a:solidFill>
+                  <a:srgbClr val="60C7F0"/>
+                </a:solidFill>
+                <a:latin typeface="Helvetica Neue"/>
+              </a:rPr>
+              <a:t>Target agent</a:t>
+            </a:r>
+          </a:p>
+        </p:txBody>
+      </p:sp>
+      <p:sp>
+        <p:nvSpPr>
+          <p:cNvPr id="130" name="TextBox 129"/>
+          <p:cNvSpPr txBox="1"/>
+          <p:nvPr/>
+        </p:nvSpPr>
+        <p:spPr>
+          <a:xfrm>
+            <a:off x="5486400" y="4864608"/>
+            <a:ext cx="1508760" cy="548640"/>
+          </a:xfrm>
+          <a:prstGeom prst="rect">
+            <a:avLst/>
+          </a:prstGeom>
+          <a:noFill/>
+        </p:spPr>
+        <p:txBody>
+          <a:bodyPr wrap="square" lIns="0" rIns="0" tIns="0" bIns="0" anchor="ctr">
+            <a:spAutoFit/>
+          </a:bodyPr>
+          <a:lstStyle/>
+          <a:p>
+            <a:pPr algn="ctr">
+              <a:spcAft>
+                <a:spcPts val="0"/>
+              </a:spcAft>
+            </a:pPr>
+            <a:r>
+              <a:rPr sz="950" b="0">
+                <a:solidFill>
+                  <a:srgbClr val="A8BBCD"/>
+                </a:solidFill>
+                <a:latin typeface="Helvetica Neue"/>
+              </a:rPr>
+              <a:t>Saved test cases</a:t>
+            </a:r>
+          </a:p>
+          <a:p>
+            <a:pPr algn="ctr">
+              <a:spcAft>
+                <a:spcPts val="0"/>
+              </a:spcAft>
+            </a:pPr>
+            <a:r>
+              <a:rPr sz="950" b="0">
+                <a:solidFill>
+                  <a:srgbClr val="A8BBCD"/>
+                </a:solidFill>
+                <a:latin typeface="Helvetica Neue"/>
+              </a:rPr>
+              <a:t>Persona-owned runner</a:t>
+            </a:r>
+          </a:p>
+          <a:p>
+            <a:pPr algn="ctr">
+              <a:spcAft>
+                <a:spcPts val="0"/>
+              </a:spcAft>
+            </a:pPr>
+            <a:r>
+              <a:rPr sz="950" b="0">
+                <a:solidFill>
+                  <a:srgbClr val="A8BBCD"/>
+                </a:solidFill>
+                <a:latin typeface="Helvetica Neue"/>
+              </a:rPr>
+              <a:t>Responses, tools &amp; SQL</a:t>
+            </a:r>
+          </a:p>
+        </p:txBody>
+      </p:sp>
+      <p:sp>
+        <p:nvSpPr>
+          <p:cNvPr id="131" name="TextBox 130"/>
+          <p:cNvSpPr txBox="1"/>
+          <p:nvPr/>
+        </p:nvSpPr>
+        <p:spPr>
+          <a:xfrm>
+            <a:off x="5349240" y="3986784"/>
+            <a:ext cx="1783080" cy="274320"/>
+          </a:xfrm>
+          <a:prstGeom prst="rect">
+            <a:avLst/>
+          </a:prstGeom>
+          <a:noFill/>
+        </p:spPr>
+        <p:txBody>
+          <a:bodyPr wrap="square" lIns="0" rIns="0" tIns="0" bIns="0" anchor="ctr">
+            <a:spAutoFit/>
+          </a:bodyPr>
+          <a:lstStyle/>
+          <a:p>
+            <a:pPr algn="ctr">
+              <a:spcAft>
+                <a:spcPts val="0"/>
+              </a:spcAft>
+            </a:pPr>
+            <a:r>
+              <a:rPr sz="1000" b="1">
                 <a:solidFill>
                   <a:srgbClr val="B9A8FF"/>
                 </a:solidFill>
                 <a:latin typeface="Helvetica Neue"/>
               </a:rPr>
-              <a:t>4</a:t>
-            </a:r>
-          </a:p>
-        </p:txBody>
-      </p:sp>
-      <p:sp>
-        <p:nvSpPr>
-          <p:cNvPr id="64" name="TextBox 63"/>
+              <a:t>4 shared task workers</a:t>
+            </a:r>
+          </a:p>
+        </p:txBody>
+      </p:sp>
+      <p:sp>
+        <p:nvSpPr>
+          <p:cNvPr id="132" name="TextBox 131"/>
           <p:cNvSpPr txBox="1"/>
           <p:nvPr/>
         </p:nvSpPr>
         <p:spPr>
           <a:xfrm>
-            <a:off x="6793992" y="4919472"/>
-            <a:ext cx="1847088" cy="502920"/>
+            <a:off x="5349240" y="5696712"/>
+            <a:ext cx="1783080" cy="365760"/>
           </a:xfrm>
           <a:prstGeom prst="rect">
             <a:avLst/>
@@ -8326,74 +9399,94 @@
           <a:noFill/>
         </p:spPr>
         <p:txBody>
-          <a:bodyPr wrap="square" lIns="0" tIns="0" rIns="0" bIns="0" anchor="t">
+          <a:bodyPr wrap="square" lIns="0" rIns="0" tIns="0" bIns="0" anchor="ctr">
             <a:spAutoFit/>
           </a:bodyPr>
           <a:lstStyle/>
           <a:p>
-            <a:pPr algn="l"/>
-            <a:r>
-              <a:rPr sz="1200" b="0">
-                <a:solidFill>
-                  <a:srgbClr val="EDF5FF"/>
-                </a:solidFill>
-                <a:latin typeface="Helvetica Neue"/>
-              </a:rPr>
-              <a:t>4 shared task workers
-Category jobs fan out</a:t>
-            </a:r>
-          </a:p>
-        </p:txBody>
-      </p:sp>
-      <p:sp>
-        <p:nvSpPr>
-          <p:cNvPr id="65" name="TextBox 64"/>
-          <p:cNvSpPr txBox="1"/>
-          <p:nvPr/>
-        </p:nvSpPr>
-        <p:spPr>
-          <a:xfrm>
-            <a:off x="6793992" y="5541264"/>
-            <a:ext cx="1847088" cy="320040"/>
-          </a:xfrm>
-          <a:prstGeom prst="rect">
-            <a:avLst/>
-          </a:prstGeom>
-          <a:noFill/>
-        </p:spPr>
-        <p:txBody>
-          <a:bodyPr wrap="square" lIns="0" tIns="0" rIns="0" bIns="0" anchor="t">
-            <a:spAutoFit/>
-          </a:bodyPr>
-          <a:lstStyle/>
-          <a:p>
-            <a:pPr algn="l"/>
-            <a:r>
-              <a:rPr sz="1100" b="0">
+            <a:pPr algn="ctr">
+              <a:spcAft>
+                <a:spcPts val="0"/>
+              </a:spcAft>
+            </a:pPr>
+            <a:r>
+              <a:rPr sz="900" b="0">
                 <a:solidFill>
                   <a:srgbClr val="A8BBCD"/>
                 </a:solidFill>
                 <a:latin typeface="Helvetica Neue"/>
               </a:rPr>
-              <a:t>Persona runner -&gt; target agent</a:t>
-            </a:r>
-          </a:p>
-        </p:txBody>
-      </p:sp>
-      <p:sp>
-        <p:nvSpPr>
-          <p:cNvPr id="66" name="Rounded Rectangle 65"/>
+              <a:t>Sequential cases</a:t>
+            </a:r>
+          </a:p>
+          <a:p>
+            <a:pPr algn="ctr">
+              <a:spcAft>
+                <a:spcPts val="0"/>
+              </a:spcAft>
+            </a:pPr>
+            <a:r>
+              <a:rPr sz="900" b="0">
+                <a:solidFill>
+                  <a:srgbClr val="A8BBCD"/>
+                </a:solidFill>
+                <a:latin typeface="Helvetica Neue"/>
+              </a:rPr>
+              <a:t>within each category</a:t>
+            </a:r>
+          </a:p>
+        </p:txBody>
+      </p:sp>
+      <p:cxnSp>
+        <p:nvCxnSpPr>
+          <p:cNvPr id="133" name="Connector 132"/>
+          <p:cNvCxnSpPr/>
+          <p:nvPr/>
+        </p:nvCxnSpPr>
+        <p:spPr>
+          <a:xfrm>
+            <a:off x="7040880" y="4901184"/>
+            <a:ext cx="365760" cy="0"/>
+          </a:xfrm>
+          <a:prstGeom prst="line">
+            <a:avLst/>
+          </a:prstGeom>
+          <a:ln w="17780">
+            <a:solidFill>
+              <a:srgbClr val="60C7F0"/>
+            </a:solidFill>
+            <a:tailEnd type="triangle"/>
+          </a:ln>
+        </p:spPr>
+        <p:style>
+          <a:lnRef idx="2">
+            <a:schemeClr val="accent1"/>
+          </a:lnRef>
+          <a:fillRef idx="0">
+            <a:schemeClr val="accent1"/>
+          </a:fillRef>
+          <a:effectRef idx="1">
+            <a:schemeClr val="accent1"/>
+          </a:effectRef>
+          <a:fontRef idx="minor">
+            <a:schemeClr val="tx1"/>
+          </a:fontRef>
+        </p:style>
+      </p:cxnSp>
+      <p:sp>
+        <p:nvSpPr>
+          <p:cNvPr id="134" name="Rounded Rectangle 133"/>
           <p:cNvSpPr/>
           <p:nvPr/>
         </p:nvSpPr>
         <p:spPr>
           <a:xfrm>
-            <a:off x="9098280" y="3776472"/>
-            <a:ext cx="2313432" cy="2194560"/>
+            <a:off x="7406640" y="4389120"/>
+            <a:ext cx="1508760" cy="1216152"/>
           </a:xfrm>
           <a:prstGeom prst="roundRect">
             <a:avLst>
-              <a:gd name="adj" fmla="val 6000"/>
+              <a:gd name="adj" fmla="val 10000"/>
             </a:avLst>
           </a:prstGeom>
           <a:solidFill>
@@ -8401,7 +9494,7 @@
           </a:solidFill>
           <a:ln w="12700">
             <a:solidFill>
-              <a:srgbClr val="304459"/>
+              <a:srgbClr val="60C7F0"/>
             </a:solidFill>
           </a:ln>
           <a:effectLst/>
@@ -8425,20 +9518,19 @@
           <a:lstStyle/>
           <a:p>
             <a:pPr algn="ctr"/>
-            <a:endParaRPr/>
-          </a:p>
-        </p:txBody>
-      </p:sp>
-      <p:sp>
-        <p:nvSpPr>
-          <p:cNvPr id="67" name="TextBox 66"/>
+          </a:p>
+        </p:txBody>
+      </p:sp>
+      <p:sp>
+        <p:nvSpPr>
+          <p:cNvPr id="135" name="TextBox 134"/>
           <p:cNvSpPr txBox="1"/>
           <p:nvPr/>
         </p:nvSpPr>
         <p:spPr>
           <a:xfrm>
-            <a:off x="9262872" y="3941063"/>
-            <a:ext cx="1984248" cy="274320"/>
+            <a:off x="7452360" y="4526280"/>
+            <a:ext cx="1417320" cy="274320"/>
           </a:xfrm>
           <a:prstGeom prst="rect">
             <a:avLst/>
@@ -8446,113 +9538,326 @@
           <a:noFill/>
         </p:spPr>
         <p:txBody>
-          <a:bodyPr wrap="square" lIns="0" tIns="0" rIns="0" bIns="0" anchor="t">
+          <a:bodyPr wrap="square" lIns="0" rIns="0" tIns="0" bIns="0" anchor="ctr">
             <a:spAutoFit/>
           </a:bodyPr>
           <a:lstStyle/>
           <a:p>
-            <a:pPr algn="l"/>
-            <a:r>
-              <a:rPr sz="1500" b="1" dirty="0">
+            <a:pPr algn="ctr">
+              <a:spcAft>
+                <a:spcPts val="0"/>
+              </a:spcAft>
+            </a:pPr>
+            <a:r>
+              <a:rPr sz="1300" b="1">
+                <a:solidFill>
+                  <a:srgbClr val="60C7F0"/>
+                </a:solidFill>
+                <a:latin typeface="Helvetica Neue"/>
+              </a:rPr>
+              <a:t>SUMMARIZER</a:t>
+            </a:r>
+          </a:p>
+        </p:txBody>
+      </p:sp>
+      <p:sp>
+        <p:nvSpPr>
+          <p:cNvPr id="136" name="TextBox 135"/>
+          <p:cNvSpPr txBox="1"/>
+          <p:nvPr/>
+        </p:nvSpPr>
+        <p:spPr>
+          <a:xfrm>
+            <a:off x="7452360" y="4892040"/>
+            <a:ext cx="1417320" cy="502920"/>
+          </a:xfrm>
+          <a:prstGeom prst="rect">
+            <a:avLst/>
+          </a:prstGeom>
+          <a:noFill/>
+        </p:spPr>
+        <p:txBody>
+          <a:bodyPr wrap="square" lIns="0" rIns="0" tIns="0" bIns="0" anchor="ctr">
+            <a:spAutoFit/>
+          </a:bodyPr>
+          <a:lstStyle/>
+          <a:p>
+            <a:pPr algn="ctr">
+              <a:spcAft>
+                <a:spcPts val="0"/>
+              </a:spcAft>
+            </a:pPr>
+            <a:r>
+              <a:rPr sz="950" b="0">
+                <a:solidFill>
+                  <a:srgbClr val="A8BBCD"/>
+                </a:solidFill>
+                <a:latin typeface="Helvetica Neue"/>
+              </a:rPr>
+              <a:t>Order validated</a:t>
+            </a:r>
+          </a:p>
+          <a:p>
+            <a:pPr algn="ctr">
+              <a:spcAft>
+                <a:spcPts val="0"/>
+              </a:spcAft>
+            </a:pPr>
+            <a:r>
+              <a:rPr sz="950" b="0">
+                <a:solidFill>
+                  <a:srgbClr val="A8BBCD"/>
+                </a:solidFill>
+                <a:latin typeface="Helvetica Neue"/>
+              </a:rPr>
+              <a:t>findings for report</a:t>
+            </a:r>
+          </a:p>
+        </p:txBody>
+      </p:sp>
+      <p:cxnSp>
+        <p:nvCxnSpPr>
+          <p:cNvPr id="137" name="Connector 136"/>
+          <p:cNvCxnSpPr/>
+          <p:nvPr/>
+        </p:nvCxnSpPr>
+        <p:spPr>
+          <a:xfrm flipV="1">
+            <a:off x="8595360" y="3246120"/>
+            <a:ext cx="0" cy="1143000"/>
+          </a:xfrm>
+          <a:prstGeom prst="line">
+            <a:avLst/>
+          </a:prstGeom>
+          <a:ln w="17780">
+            <a:solidFill>
+              <a:srgbClr val="60C7F0"/>
+            </a:solidFill>
+          </a:ln>
+        </p:spPr>
+        <p:style>
+          <a:lnRef idx="2">
+            <a:schemeClr val="accent1"/>
+          </a:lnRef>
+          <a:fillRef idx="0">
+            <a:schemeClr val="accent1"/>
+          </a:fillRef>
+          <a:effectRef idx="1">
+            <a:schemeClr val="accent1"/>
+          </a:effectRef>
+          <a:fontRef idx="minor">
+            <a:schemeClr val="tx1"/>
+          </a:fontRef>
+        </p:style>
+      </p:cxnSp>
+      <p:cxnSp>
+        <p:nvCxnSpPr>
+          <p:cNvPr id="138" name="Connector 137"/>
+          <p:cNvCxnSpPr/>
+          <p:nvPr/>
+        </p:nvCxnSpPr>
+        <p:spPr>
+          <a:xfrm flipH="1">
+            <a:off x="7498079" y="3246120"/>
+            <a:ext cx="1097281" cy="0"/>
+          </a:xfrm>
+          <a:prstGeom prst="line">
+            <a:avLst/>
+          </a:prstGeom>
+          <a:ln w="17780">
+            <a:solidFill>
+              <a:srgbClr val="60C7F0"/>
+            </a:solidFill>
+          </a:ln>
+        </p:spPr>
+        <p:style>
+          <a:lnRef idx="2">
+            <a:schemeClr val="accent1"/>
+          </a:lnRef>
+          <a:fillRef idx="0">
+            <a:schemeClr val="accent1"/>
+          </a:fillRef>
+          <a:effectRef idx="1">
+            <a:schemeClr val="accent1"/>
+          </a:effectRef>
+          <a:fontRef idx="minor">
+            <a:schemeClr val="tx1"/>
+          </a:fontRef>
+        </p:style>
+      </p:cxnSp>
+      <p:cxnSp>
+        <p:nvCxnSpPr>
+          <p:cNvPr id="139" name="Connector 138"/>
+          <p:cNvCxnSpPr/>
+          <p:nvPr/>
+        </p:nvCxnSpPr>
+        <p:spPr>
+          <a:xfrm flipV="1">
+            <a:off x="7498079" y="2935224"/>
+            <a:ext cx="0" cy="310896"/>
+          </a:xfrm>
+          <a:prstGeom prst="line">
+            <a:avLst/>
+          </a:prstGeom>
+          <a:ln w="17780">
+            <a:solidFill>
+              <a:srgbClr val="60C7F0"/>
+            </a:solidFill>
+            <a:tailEnd type="triangle"/>
+          </a:ln>
+        </p:spPr>
+        <p:style>
+          <a:lnRef idx="2">
+            <a:schemeClr val="accent1"/>
+          </a:lnRef>
+          <a:fillRef idx="0">
+            <a:schemeClr val="accent1"/>
+          </a:fillRef>
+          <a:effectRef idx="1">
+            <a:schemeClr val="accent1"/>
+          </a:effectRef>
+          <a:fontRef idx="minor">
+            <a:schemeClr val="tx1"/>
+          </a:fontRef>
+        </p:style>
+      </p:cxnSp>
+      <p:sp>
+        <p:nvSpPr>
+          <p:cNvPr id="140" name="TextBox 139"/>
+          <p:cNvSpPr txBox="1"/>
+          <p:nvPr/>
+        </p:nvSpPr>
+        <p:spPr>
+          <a:xfrm>
+            <a:off x="7543800" y="3291840"/>
+            <a:ext cx="1024128" cy="182880"/>
+          </a:xfrm>
+          <a:prstGeom prst="rect">
+            <a:avLst/>
+          </a:prstGeom>
+          <a:noFill/>
+        </p:spPr>
+        <p:txBody>
+          <a:bodyPr wrap="square" lIns="0" rIns="0" tIns="0" bIns="0" anchor="ctr">
+            <a:spAutoFit/>
+          </a:bodyPr>
+          <a:lstStyle/>
+          <a:p>
+            <a:pPr algn="l">
+              <a:spcAft>
+                <a:spcPts val="0"/>
+              </a:spcAft>
+            </a:pPr>
+            <a:r>
+              <a:rPr sz="850" b="0">
+                <a:solidFill>
+                  <a:srgbClr val="60C7F0"/>
+                </a:solidFill>
+                <a:latin typeface="Helvetica Neue"/>
+              </a:rPr>
+              <a:t>results &amp; report</a:t>
+            </a:r>
+          </a:p>
+        </p:txBody>
+      </p:sp>
+      <p:cxnSp>
+        <p:nvCxnSpPr>
+          <p:cNvPr id="141" name="Connector 140"/>
+          <p:cNvCxnSpPr/>
+          <p:nvPr/>
+        </p:nvCxnSpPr>
+        <p:spPr>
+          <a:xfrm>
+            <a:off x="9418320" y="2935224"/>
+            <a:ext cx="0" cy="1453896"/>
+          </a:xfrm>
+          <a:prstGeom prst="line">
+            <a:avLst/>
+          </a:prstGeom>
+          <a:ln w="17780">
+            <a:solidFill>
+              <a:srgbClr val="61D2BD"/>
+            </a:solidFill>
+            <a:tailEnd type="triangle"/>
+          </a:ln>
+        </p:spPr>
+        <p:style>
+          <a:lnRef idx="2">
+            <a:schemeClr val="accent1"/>
+          </a:lnRef>
+          <a:fillRef idx="0">
+            <a:schemeClr val="accent1"/>
+          </a:fillRef>
+          <a:effectRef idx="1">
+            <a:schemeClr val="accent1"/>
+          </a:effectRef>
+          <a:fontRef idx="minor">
+            <a:schemeClr val="tx1"/>
+          </a:fontRef>
+        </p:style>
+      </p:cxnSp>
+      <p:sp>
+        <p:nvSpPr>
+          <p:cNvPr id="142" name="TextBox 141"/>
+          <p:cNvSpPr txBox="1"/>
+          <p:nvPr/>
+        </p:nvSpPr>
+        <p:spPr>
+          <a:xfrm>
+            <a:off x="9491472" y="3291840"/>
+            <a:ext cx="1463040" cy="182880"/>
+          </a:xfrm>
+          <a:prstGeom prst="rect">
+            <a:avLst/>
+          </a:prstGeom>
+          <a:noFill/>
+        </p:spPr>
+        <p:txBody>
+          <a:bodyPr wrap="square" lIns="0" rIns="0" tIns="0" bIns="0" anchor="ctr">
+            <a:spAutoFit/>
+          </a:bodyPr>
+          <a:lstStyle/>
+          <a:p>
+            <a:pPr algn="l">
+              <a:spcAft>
+                <a:spcPts val="0"/>
+              </a:spcAft>
+            </a:pPr>
+            <a:r>
+              <a:rPr sz="850" b="0">
                 <a:solidFill>
                   <a:srgbClr val="61D2BD"/>
                 </a:solidFill>
                 <a:latin typeface="Helvetica Neue"/>
               </a:rPr>
-              <a:t>Evidence to action</a:t>
-            </a:r>
-          </a:p>
-        </p:txBody>
-      </p:sp>
-      <p:sp>
-        <p:nvSpPr>
-          <p:cNvPr id="68" name="TextBox 67"/>
-          <p:cNvSpPr txBox="1"/>
-          <p:nvPr/>
-        </p:nvSpPr>
-        <p:spPr>
-          <a:xfrm>
-            <a:off x="9262872" y="4416552"/>
-            <a:ext cx="1984248" cy="228600"/>
-          </a:xfrm>
-          <a:prstGeom prst="rect">
-            <a:avLst/>
-          </a:prstGeom>
-          <a:noFill/>
-        </p:spPr>
-        <p:txBody>
-          <a:bodyPr wrap="square" lIns="0" tIns="0" rIns="0" bIns="0" anchor="t">
-            <a:spAutoFit/>
-          </a:bodyPr>
-          <a:lstStyle/>
-          <a:p>
-            <a:pPr algn="l"/>
-            <a:r>
-              <a:rPr sz="1300" b="1">
-                <a:solidFill>
-                  <a:srgbClr val="61D2BD"/>
-                </a:solidFill>
-                <a:latin typeface="Helvetica Neue"/>
-              </a:rPr>
-              <a:t>SUMMARIZER</a:t>
-            </a:r>
-          </a:p>
-        </p:txBody>
-      </p:sp>
-      <p:sp>
-        <p:nvSpPr>
-          <p:cNvPr id="69" name="TextBox 68"/>
-          <p:cNvSpPr txBox="1"/>
-          <p:nvPr/>
-        </p:nvSpPr>
-        <p:spPr>
-          <a:xfrm>
-            <a:off x="9262872" y="4718304"/>
-            <a:ext cx="1984248" cy="320040"/>
-          </a:xfrm>
-          <a:prstGeom prst="rect">
-            <a:avLst/>
-          </a:prstGeom>
-          <a:noFill/>
-        </p:spPr>
-        <p:txBody>
-          <a:bodyPr wrap="square" lIns="0" tIns="0" rIns="0" bIns="0" anchor="t">
-            <a:spAutoFit/>
-          </a:bodyPr>
-          <a:lstStyle/>
-          <a:p>
-            <a:pPr algn="l"/>
-            <a:r>
-              <a:rPr sz="1150" b="0" dirty="0">
-                <a:solidFill>
-                  <a:srgbClr val="A8BBCD"/>
-                </a:solidFill>
-                <a:latin typeface="Helvetica Neue"/>
-              </a:rPr>
-              <a:t>Order validated findings</a:t>
-            </a:r>
-          </a:p>
-        </p:txBody>
-      </p:sp>
-      <p:sp>
-        <p:nvSpPr>
-          <p:cNvPr id="70" name="Rectangle 69"/>
+              <a:t>selected findings</a:t>
+            </a:r>
+          </a:p>
+        </p:txBody>
+      </p:sp>
+      <p:sp>
+        <p:nvSpPr>
+          <p:cNvPr id="143" name="Rounded Rectangle 142"/>
           <p:cNvSpPr/>
           <p:nvPr/>
         </p:nvSpPr>
         <p:spPr>
           <a:xfrm>
-            <a:off x="9262872" y="5166360"/>
-            <a:ext cx="1984248" cy="11887"/>
-          </a:xfrm>
-          <a:prstGeom prst="rect">
-            <a:avLst/>
+            <a:off x="9189720" y="4389120"/>
+            <a:ext cx="2221992" cy="1216152"/>
+          </a:xfrm>
+          <a:prstGeom prst="roundRect">
+            <a:avLst>
+              <a:gd name="adj" fmla="val 10000"/>
+            </a:avLst>
           </a:prstGeom>
           <a:solidFill>
-            <a:srgbClr val="304459"/>
+            <a:srgbClr val="122132"/>
           </a:solidFill>
-          <a:ln>
-            <a:noFill/>
+          <a:ln w="12700">
+            <a:solidFill>
+              <a:srgbClr val="61D2BD"/>
+            </a:solidFill>
           </a:ln>
           <a:effectLst/>
         </p:spPr>
@@ -8575,20 +9880,19 @@
           <a:lstStyle/>
           <a:p>
             <a:pPr algn="ctr"/>
-            <a:endParaRPr/>
-          </a:p>
-        </p:txBody>
-      </p:sp>
-      <p:sp>
-        <p:nvSpPr>
-          <p:cNvPr id="71" name="TextBox 70"/>
+          </a:p>
+        </p:txBody>
+      </p:sp>
+      <p:sp>
+        <p:nvSpPr>
+          <p:cNvPr id="144" name="TextBox 143"/>
           <p:cNvSpPr txBox="1"/>
           <p:nvPr/>
         </p:nvSpPr>
         <p:spPr>
           <a:xfrm>
-            <a:off x="9262872" y="5340096"/>
-            <a:ext cx="1984248" cy="228600"/>
+            <a:off x="9281160" y="4526280"/>
+            <a:ext cx="2039112" cy="274320"/>
           </a:xfrm>
           <a:prstGeom prst="rect">
             <a:avLst/>
@@ -8596,12 +9900,16 @@
           <a:noFill/>
         </p:spPr>
         <p:txBody>
-          <a:bodyPr wrap="square" lIns="0" tIns="0" rIns="0" bIns="0" anchor="t">
+          <a:bodyPr wrap="square" lIns="0" rIns="0" tIns="0" bIns="0" anchor="ctr">
             <a:spAutoFit/>
           </a:bodyPr>
           <a:lstStyle/>
           <a:p>
-            <a:pPr algn="l"/>
+            <a:pPr algn="ctr">
+              <a:spcAft>
+                <a:spcPts val="0"/>
+              </a:spcAft>
+            </a:pPr>
             <a:r>
               <a:rPr sz="1300" b="1">
                 <a:solidFill>
@@ -8616,14 +9924,14 @@
       </p:sp>
       <p:sp>
         <p:nvSpPr>
-          <p:cNvPr id="72" name="TextBox 71"/>
+          <p:cNvPr id="145" name="TextBox 144"/>
           <p:cNvSpPr txBox="1"/>
           <p:nvPr/>
         </p:nvSpPr>
         <p:spPr>
           <a:xfrm>
-            <a:off x="9262872" y="5641848"/>
-            <a:ext cx="1984248" cy="228600"/>
+            <a:off x="9281160" y="4892040"/>
+            <a:ext cx="2039112" cy="502920"/>
           </a:xfrm>
           <a:prstGeom prst="rect">
             <a:avLst/>
@@ -8631,14 +9939,18 @@
           <a:noFill/>
         </p:spPr>
         <p:txBody>
-          <a:bodyPr wrap="square" lIns="0" tIns="0" rIns="0" bIns="0" anchor="t">
+          <a:bodyPr wrap="square" lIns="0" rIns="0" tIns="0" bIns="0" anchor="ctr">
             <a:spAutoFit/>
           </a:bodyPr>
           <a:lstStyle/>
           <a:p>
-            <a:pPr algn="l"/>
-            <a:r>
-              <a:rPr sz="1100" b="0">
+            <a:pPr algn="ctr">
+              <a:spcAft>
+                <a:spcPts val="0"/>
+              </a:spcAft>
+            </a:pPr>
+            <a:r>
+              <a:rPr sz="950" b="0">
                 <a:solidFill>
                   <a:srgbClr val="A8BBCD"/>
                 </a:solidFill>
@@ -8647,264 +9959,111 @@
               <a:t>Select reviewed fix recipes</a:t>
             </a:r>
           </a:p>
-        </p:txBody>
-      </p:sp>
-      <p:sp>
-        <p:nvSpPr>
-          <p:cNvPr id="73" name="Chevron 72"/>
-          <p:cNvSpPr/>
-          <p:nvPr/>
-        </p:nvSpPr>
-        <p:spPr>
-          <a:xfrm>
-            <a:off x="2724912" y="4782312"/>
-            <a:ext cx="128016" cy="210312"/>
-          </a:xfrm>
-          <a:prstGeom prst="chevron">
-            <a:avLst/>
-          </a:prstGeom>
-          <a:solidFill>
-            <a:srgbClr val="29B5E8"/>
-          </a:solidFill>
-          <a:ln>
-            <a:noFill/>
-          </a:ln>
-          <a:effectLst/>
-        </p:spPr>
-        <p:style>
-          <a:lnRef idx="1">
-            <a:schemeClr val="accent1"/>
-          </a:lnRef>
-          <a:fillRef idx="3">
-            <a:schemeClr val="accent1"/>
-          </a:fillRef>
-          <a:effectRef idx="2">
-            <a:schemeClr val="accent1"/>
-          </a:effectRef>
-          <a:fontRef idx="minor">
-            <a:schemeClr val="lt1"/>
-          </a:fontRef>
-        </p:style>
-        <p:txBody>
-          <a:bodyPr rtlCol="0" anchor="ctr"/>
-          <a:lstStyle/>
-          <a:p>
-            <a:pPr algn="ctr"/>
-            <a:endParaRPr/>
-          </a:p>
-        </p:txBody>
-      </p:sp>
-      <p:sp>
-        <p:nvSpPr>
-          <p:cNvPr id="74" name="Chevron 73"/>
-          <p:cNvSpPr/>
-          <p:nvPr/>
-        </p:nvSpPr>
-        <p:spPr>
-          <a:xfrm>
-            <a:off x="6428232" y="4782312"/>
-            <a:ext cx="128016" cy="210312"/>
-          </a:xfrm>
-          <a:prstGeom prst="chevron">
-            <a:avLst/>
-          </a:prstGeom>
-          <a:solidFill>
-            <a:srgbClr val="29B5E8"/>
-          </a:solidFill>
-          <a:ln>
-            <a:noFill/>
-          </a:ln>
-          <a:effectLst/>
-        </p:spPr>
-        <p:style>
-          <a:lnRef idx="1">
-            <a:schemeClr val="accent1"/>
-          </a:lnRef>
-          <a:fillRef idx="3">
-            <a:schemeClr val="accent1"/>
-          </a:fillRef>
-          <a:effectRef idx="2">
-            <a:schemeClr val="accent1"/>
-          </a:effectRef>
-          <a:fontRef idx="minor">
-            <a:schemeClr val="lt1"/>
-          </a:fontRef>
-        </p:style>
-        <p:txBody>
-          <a:bodyPr rtlCol="0" anchor="ctr"/>
-          <a:lstStyle/>
-          <a:p>
-            <a:pPr algn="ctr"/>
-            <a:endParaRPr/>
-          </a:p>
-        </p:txBody>
-      </p:sp>
-      <p:sp>
-        <p:nvSpPr>
-          <p:cNvPr id="75" name="Chevron 74"/>
-          <p:cNvSpPr/>
-          <p:nvPr/>
-        </p:nvSpPr>
-        <p:spPr>
-          <a:xfrm>
-            <a:off x="8897112" y="4782312"/>
-            <a:ext cx="128016" cy="210312"/>
-          </a:xfrm>
-          <a:prstGeom prst="chevron">
-            <a:avLst/>
-          </a:prstGeom>
-          <a:solidFill>
-            <a:srgbClr val="29B5E8"/>
-          </a:solidFill>
-          <a:ln>
-            <a:noFill/>
-          </a:ln>
-          <a:effectLst/>
-        </p:spPr>
-        <p:style>
-          <a:lnRef idx="1">
-            <a:schemeClr val="accent1"/>
-          </a:lnRef>
-          <a:fillRef idx="3">
-            <a:schemeClr val="accent1"/>
-          </a:fillRef>
-          <a:effectRef idx="2">
-            <a:schemeClr val="accent1"/>
-          </a:effectRef>
-          <a:fontRef idx="minor">
-            <a:schemeClr val="lt1"/>
-          </a:fontRef>
-        </p:style>
-        <p:txBody>
-          <a:bodyPr rtlCol="0" anchor="ctr"/>
-          <a:lstStyle/>
-          <a:p>
-            <a:pPr algn="ctr"/>
-            <a:endParaRPr/>
-          </a:p>
-        </p:txBody>
-      </p:sp>
-      <p:sp>
-        <p:nvSpPr>
-          <p:cNvPr id="76" name="Rectangle 75"/>
-          <p:cNvSpPr/>
-          <p:nvPr/>
-        </p:nvSpPr>
-        <p:spPr>
-          <a:xfrm>
-            <a:off x="777240" y="6263640"/>
-            <a:ext cx="10637215" cy="13716"/>
-          </a:xfrm>
-          <a:prstGeom prst="rect">
-            <a:avLst/>
-          </a:prstGeom>
-          <a:solidFill>
-            <a:srgbClr val="304459"/>
-          </a:solidFill>
-          <a:ln>
-            <a:noFill/>
-          </a:ln>
-          <a:effectLst/>
-        </p:spPr>
-        <p:style>
-          <a:lnRef idx="1">
-            <a:schemeClr val="accent1"/>
-          </a:lnRef>
-          <a:fillRef idx="3">
-            <a:schemeClr val="accent1"/>
-          </a:fillRef>
-          <a:effectRef idx="2">
-            <a:schemeClr val="accent1"/>
-          </a:effectRef>
-          <a:fontRef idx="minor">
-            <a:schemeClr val="lt1"/>
-          </a:fontRef>
-        </p:style>
-        <p:txBody>
-          <a:bodyPr rtlCol="0" anchor="ctr"/>
-          <a:lstStyle/>
-          <a:p>
-            <a:pPr algn="ctr"/>
-            <a:endParaRPr/>
-          </a:p>
-        </p:txBody>
-      </p:sp>
-      <p:sp>
-        <p:nvSpPr>
-          <p:cNvPr id="77" name="Rectangle 76"/>
-          <p:cNvSpPr/>
-          <p:nvPr/>
-        </p:nvSpPr>
-        <p:spPr>
-          <a:xfrm>
-            <a:off x="777240" y="6252667"/>
-            <a:ext cx="1097280" cy="36576"/>
-          </a:xfrm>
-          <a:prstGeom prst="rect">
-            <a:avLst/>
-          </a:prstGeom>
-          <a:solidFill>
-            <a:srgbClr val="29B5E8"/>
-          </a:solidFill>
-          <a:ln>
-            <a:noFill/>
-          </a:ln>
-          <a:effectLst/>
-        </p:spPr>
-        <p:style>
-          <a:lnRef idx="1">
-            <a:schemeClr val="accent1"/>
-          </a:lnRef>
-          <a:fillRef idx="3">
-            <a:schemeClr val="accent1"/>
-          </a:fillRef>
-          <a:effectRef idx="2">
-            <a:schemeClr val="accent1"/>
-          </a:effectRef>
-          <a:fontRef idx="minor">
-            <a:schemeClr val="lt1"/>
-          </a:fontRef>
-        </p:style>
-        <p:txBody>
-          <a:bodyPr rtlCol="0" anchor="ctr"/>
-          <a:lstStyle/>
-          <a:p>
-            <a:pPr algn="ctr"/>
-            <a:endParaRPr/>
-          </a:p>
-        </p:txBody>
-      </p:sp>
-      <p:sp>
-        <p:nvSpPr>
-          <p:cNvPr id="78" name="TextBox 77"/>
-          <p:cNvSpPr txBox="1"/>
-          <p:nvPr/>
-        </p:nvSpPr>
-        <p:spPr>
-          <a:xfrm>
-            <a:off x="777240" y="6382512"/>
-            <a:ext cx="5486400" cy="274320"/>
-          </a:xfrm>
-          <a:prstGeom prst="rect">
-            <a:avLst/>
-          </a:prstGeom>
-          <a:noFill/>
-        </p:spPr>
-        <p:txBody>
-          <a:bodyPr wrap="square" lIns="0" tIns="0" rIns="0" bIns="0" anchor="t">
-            <a:spAutoFit/>
-          </a:bodyPr>
-          <a:lstStyle/>
-          <a:p>
-            <a:pPr algn="l"/>
-            <a:r>
-              <a:rPr sz="1000" b="0" spc="100">
+          <a:p>
+            <a:pPr algn="ctr">
+              <a:spcAft>
+                <a:spcPts val="0"/>
+              </a:spcAft>
+            </a:pPr>
+            <a:r>
+              <a:rPr sz="950" b="0">
                 <a:solidFill>
                   <a:srgbClr val="A8BBCD"/>
                 </a:solidFill>
                 <a:latin typeface="Helvetica Neue"/>
               </a:rPr>
-              <a:t>SAVED CASES  ·  REAL EXECUTION  ·  HUMAN APPROVAL</a:t>
+              <a:t>Preview → human approval</a:t>
+            </a:r>
+          </a:p>
+        </p:txBody>
+      </p:sp>
+      <p:cxnSp>
+        <p:nvCxnSpPr>
+          <p:cNvPr id="146" name="Connector 145"/>
+          <p:cNvCxnSpPr/>
+          <p:nvPr/>
+        </p:nvCxnSpPr>
+        <p:spPr>
+          <a:xfrm flipV="1">
+            <a:off x="11155680" y="2935224"/>
+            <a:ext cx="0" cy="1453896"/>
+          </a:xfrm>
+          <a:prstGeom prst="line">
+            <a:avLst/>
+          </a:prstGeom>
+          <a:ln w="17780">
+            <a:solidFill>
+              <a:srgbClr val="61D2BD"/>
+            </a:solidFill>
+            <a:tailEnd type="triangle"/>
+          </a:ln>
+        </p:spPr>
+        <p:style>
+          <a:lnRef idx="2">
+            <a:schemeClr val="accent1"/>
+          </a:lnRef>
+          <a:fillRef idx="0">
+            <a:schemeClr val="accent1"/>
+          </a:fillRef>
+          <a:effectRef idx="1">
+            <a:schemeClr val="accent1"/>
+          </a:effectRef>
+          <a:fontRef idx="minor">
+            <a:schemeClr val="tx1"/>
+          </a:fontRef>
+        </p:style>
+      </p:cxnSp>
+      <p:sp>
+        <p:nvSpPr>
+          <p:cNvPr id="147" name="TextBox 146"/>
+          <p:cNvSpPr txBox="1"/>
+          <p:nvPr/>
+        </p:nvSpPr>
+        <p:spPr>
+          <a:xfrm>
+            <a:off x="9710928" y="5696712"/>
+            <a:ext cx="1700784" cy="365760"/>
+          </a:xfrm>
+          <a:prstGeom prst="rect">
+            <a:avLst/>
+          </a:prstGeom>
+          <a:noFill/>
+        </p:spPr>
+        <p:txBody>
+          <a:bodyPr wrap="square" lIns="0" rIns="0" tIns="0" bIns="0" anchor="ctr">
+            <a:spAutoFit/>
+          </a:bodyPr>
+          <a:lstStyle/>
+          <a:p>
+            <a:pPr algn="ctr">
+              <a:spcAft>
+                <a:spcPts val="0"/>
+              </a:spcAft>
+            </a:pPr>
+            <a:r>
+              <a:rPr sz="900" b="0">
+                <a:solidFill>
+                  <a:srgbClr val="A8BBCD"/>
+                </a:solidFill>
+                <a:latin typeface="Helvetica Neue"/>
+              </a:rPr>
+              <a:t>Approved fixes → Testbot</a:t>
+            </a:r>
+          </a:p>
+          <a:p>
+            <a:pPr algn="ctr">
+              <a:spcAft>
+                <a:spcPts val="0"/>
+              </a:spcAft>
+            </a:pPr>
+            <a:r>
+              <a:rPr sz="900" b="0">
+                <a:solidFill>
+                  <a:srgbClr val="A8BBCD"/>
+                </a:solidFill>
+                <a:latin typeface="Helvetica Neue"/>
+              </a:rPr>
+              <a:t>retests saved cases</a:t>
             </a:r>
           </a:p>
         </p:txBody>

</xml_diff>